<commit_message>
Add pipeline step 1 Acquire FakeNewsNet
</commit_message>
<xml_diff>
--- a/poster/A0 Academic poster template landscape v2.pptx
+++ b/poster/A0 Academic poster template landscape v2.pptx
@@ -616,259 +616,7 @@
 </c:chartSpace>
 </file>
 
-<file path=ppt/charts/chart2.xml><?xml version="1.0" encoding="utf-8"?>
-<c:chartSpace xmlns:c="http://schemas.openxmlformats.org/drawingml/2006/chart" xmlns:a="http://schemas.openxmlformats.org/drawingml/2006/main" xmlns:r="http://schemas.openxmlformats.org/officeDocument/2006/relationships" xmlns:c16r2="http://schemas.microsoft.com/office/drawing/2015/06/chart">
-  <c:date1904 val="0"/>
-  <c:lang val="en-GB"/>
-  <c:roundedCorners val="0"/>
-  <mc:AlternateContent xmlns:mc="http://schemas.openxmlformats.org/markup-compatibility/2006">
-    <mc:Choice xmlns:c14="http://schemas.microsoft.com/office/drawing/2007/8/2/chart" Requires="c14">
-      <c14:style val="102"/>
-    </mc:Choice>
-    <mc:Fallback>
-      <c:style val="2"/>
-    </mc:Fallback>
-  </mc:AlternateContent>
-  <c:chart>
-    <c:autoTitleDeleted val="1"/>
-    <c:plotArea>
-      <c:layout>
-        <c:manualLayout>
-          <c:layoutTarget val="inner"/>
-          <c:xMode val="edge"/>
-          <c:yMode val="edge"/>
-          <c:x val="0.12178572840776829"/>
-          <c:y val="4.0028859747700707E-2"/>
-          <c:w val="0.73216843716290414"/>
-          <c:h val="0.95997114025229935"/>
-        </c:manualLayout>
-      </c:layout>
-      <c:doughnutChart>
-        <c:varyColors val="1"/>
-        <c:ser>
-          <c:idx val="0"/>
-          <c:order val="0"/>
-          <c:tx>
-            <c:strRef>
-              <c:f>Sheet1!$B$1</c:f>
-              <c:strCache>
-                <c:ptCount val="1"/>
-                <c:pt idx="0">
-                  <c:v>Sales</c:v>
-                </c:pt>
-              </c:strCache>
-            </c:strRef>
-          </c:tx>
-          <c:dPt>
-            <c:idx val="0"/>
-            <c:bubble3D val="0"/>
-            <c:spPr>
-              <a:solidFill>
-                <a:schemeClr val="accent1"/>
-              </a:solidFill>
-              <a:ln w="19050">
-                <a:solidFill>
-                  <a:schemeClr val="lt1"/>
-                </a:solidFill>
-              </a:ln>
-              <a:effectLst/>
-            </c:spPr>
-            <c:extLst>
-              <c:ext xmlns:c16="http://schemas.microsoft.com/office/drawing/2014/chart" uri="{C3380CC4-5D6E-409C-BE32-E72D297353CC}">
-                <c16:uniqueId val="{00000001-3641-6344-A7B5-3D29DAAA1964}"/>
-              </c:ext>
-            </c:extLst>
-          </c:dPt>
-          <c:dPt>
-            <c:idx val="1"/>
-            <c:bubble3D val="0"/>
-            <c:spPr>
-              <a:solidFill>
-                <a:schemeClr val="accent2"/>
-              </a:solidFill>
-              <a:ln w="19050">
-                <a:solidFill>
-                  <a:schemeClr val="lt1"/>
-                </a:solidFill>
-              </a:ln>
-              <a:effectLst/>
-            </c:spPr>
-            <c:extLst>
-              <c:ext xmlns:c16="http://schemas.microsoft.com/office/drawing/2014/chart" uri="{C3380CC4-5D6E-409C-BE32-E72D297353CC}">
-                <c16:uniqueId val="{00000003-3641-6344-A7B5-3D29DAAA1964}"/>
-              </c:ext>
-            </c:extLst>
-          </c:dPt>
-          <c:dPt>
-            <c:idx val="2"/>
-            <c:bubble3D val="0"/>
-            <c:spPr>
-              <a:solidFill>
-                <a:schemeClr val="accent3"/>
-              </a:solidFill>
-              <a:ln w="19050">
-                <a:solidFill>
-                  <a:schemeClr val="lt1"/>
-                </a:solidFill>
-              </a:ln>
-              <a:effectLst/>
-            </c:spPr>
-            <c:extLst>
-              <c:ext xmlns:c16="http://schemas.microsoft.com/office/drawing/2014/chart" uri="{C3380CC4-5D6E-409C-BE32-E72D297353CC}">
-                <c16:uniqueId val="{00000005-3641-6344-A7B5-3D29DAAA1964}"/>
-              </c:ext>
-            </c:extLst>
-          </c:dPt>
-          <c:dPt>
-            <c:idx val="3"/>
-            <c:bubble3D val="0"/>
-            <c:spPr>
-              <a:solidFill>
-                <a:schemeClr val="accent4"/>
-              </a:solidFill>
-              <a:ln w="19050">
-                <a:solidFill>
-                  <a:schemeClr val="lt1"/>
-                </a:solidFill>
-              </a:ln>
-              <a:effectLst/>
-            </c:spPr>
-            <c:extLst>
-              <c:ext xmlns:c16="http://schemas.microsoft.com/office/drawing/2014/chart" uri="{C3380CC4-5D6E-409C-BE32-E72D297353CC}">
-                <c16:uniqueId val="{00000007-3641-6344-A7B5-3D29DAAA1964}"/>
-              </c:ext>
-            </c:extLst>
-          </c:dPt>
-          <c:cat>
-            <c:strRef>
-              <c:f>Sheet1!$A$2:$A$5</c:f>
-              <c:strCache>
-                <c:ptCount val="2"/>
-                <c:pt idx="0">
-                  <c:v>1st Qtr</c:v>
-                </c:pt>
-                <c:pt idx="1">
-                  <c:v>2nd Qtr</c:v>
-                </c:pt>
-              </c:strCache>
-            </c:strRef>
-          </c:cat>
-          <c:val>
-            <c:numRef>
-              <c:f>Sheet1!$B$2:$B$5</c:f>
-              <c:numCache>
-                <c:formatCode>General</c:formatCode>
-                <c:ptCount val="4"/>
-                <c:pt idx="0">
-                  <c:v>4</c:v>
-                </c:pt>
-                <c:pt idx="1">
-                  <c:v>6</c:v>
-                </c:pt>
-              </c:numCache>
-            </c:numRef>
-          </c:val>
-          <c:extLst>
-            <c:ext xmlns:c16="http://schemas.microsoft.com/office/drawing/2014/chart" uri="{C3380CC4-5D6E-409C-BE32-E72D297353CC}">
-              <c16:uniqueId val="{00000008-3641-6344-A7B5-3D29DAAA1964}"/>
-            </c:ext>
-          </c:extLst>
-        </c:ser>
-        <c:dLbls>
-          <c:showLegendKey val="0"/>
-          <c:showVal val="0"/>
-          <c:showCatName val="0"/>
-          <c:showSerName val="0"/>
-          <c:showPercent val="0"/>
-          <c:showBubbleSize val="0"/>
-          <c:showLeaderLines val="1"/>
-        </c:dLbls>
-        <c:firstSliceAng val="0"/>
-        <c:holeSize val="75"/>
-      </c:doughnutChart>
-      <c:spPr>
-        <a:noFill/>
-        <a:ln>
-          <a:noFill/>
-        </a:ln>
-        <a:effectLst/>
-      </c:spPr>
-    </c:plotArea>
-    <c:plotVisOnly val="1"/>
-    <c:dispBlanksAs val="gap"/>
-    <c:showDLblsOverMax val="0"/>
-    <c:extLst>
-      <c:ext xmlns:c16r3="http://schemas.microsoft.com/office/drawing/2017/03/chart" uri="{56B9EC1D-385E-4148-901F-78D8002777C0}">
-        <c16r3:dataDisplayOptions16>
-          <c16r3:dispNaAsBlank val="1"/>
-        </c16r3:dataDisplayOptions16>
-      </c:ext>
-    </c:extLst>
-  </c:chart>
-  <c:spPr>
-    <a:noFill/>
-    <a:ln>
-      <a:noFill/>
-    </a:ln>
-    <a:effectLst/>
-  </c:spPr>
-  <c:txPr>
-    <a:bodyPr/>
-    <a:lstStyle/>
-    <a:p>
-      <a:pPr>
-        <a:defRPr/>
-      </a:pPr>
-      <a:endParaRPr lang="en-US"/>
-    </a:p>
-  </c:txPr>
-  <c:externalData r:id="rId3">
-    <c:autoUpdate val="0"/>
-  </c:externalData>
-</c:chartSpace>
-</file>
-
 <file path=ppt/charts/colors1.xml><?xml version="1.0" encoding="utf-8"?>
-<cs:colorStyle xmlns:cs="http://schemas.microsoft.com/office/drawing/2012/chartStyle" xmlns:a="http://schemas.openxmlformats.org/drawingml/2006/main" meth="cycle" id="10">
-  <a:schemeClr val="accent1"/>
-  <a:schemeClr val="accent2"/>
-  <a:schemeClr val="accent3"/>
-  <a:schemeClr val="accent4"/>
-  <a:schemeClr val="accent5"/>
-  <a:schemeClr val="accent6"/>
-  <cs:variation/>
-  <cs:variation>
-    <a:lumMod val="60000"/>
-  </cs:variation>
-  <cs:variation>
-    <a:lumMod val="80000"/>
-    <a:lumOff val="20000"/>
-  </cs:variation>
-  <cs:variation>
-    <a:lumMod val="80000"/>
-  </cs:variation>
-  <cs:variation>
-    <a:lumMod val="60000"/>
-    <a:lumOff val="40000"/>
-  </cs:variation>
-  <cs:variation>
-    <a:lumMod val="50000"/>
-  </cs:variation>
-  <cs:variation>
-    <a:lumMod val="70000"/>
-    <a:lumOff val="30000"/>
-  </cs:variation>
-  <cs:variation>
-    <a:lumMod val="70000"/>
-  </cs:variation>
-  <cs:variation>
-    <a:lumMod val="50000"/>
-    <a:lumOff val="50000"/>
-  </cs:variation>
-</cs:colorStyle>
-</file>
-
-<file path=ppt/charts/colors2.xml><?xml version="1.0" encoding="utf-8"?>
 <cs:colorStyle xmlns:cs="http://schemas.microsoft.com/office/drawing/2012/chartStyle" xmlns:a="http://schemas.openxmlformats.org/drawingml/2006/main" meth="cycle" id="10">
   <a:schemeClr val="accent1"/>
   <a:schemeClr val="accent2"/>
@@ -1413,525 +1161,6 @@
 </cs:chartStyle>
 </file>
 
-<file path=ppt/charts/style2.xml><?xml version="1.0" encoding="utf-8"?>
-<cs:chartStyle xmlns:cs="http://schemas.microsoft.com/office/drawing/2012/chartStyle" xmlns:a="http://schemas.openxmlformats.org/drawingml/2006/main" id="251">
-  <cs:axisTitle>
-    <cs:lnRef idx="0"/>
-    <cs:fillRef idx="0"/>
-    <cs:effectRef idx="0"/>
-    <cs:fontRef idx="minor">
-      <a:schemeClr val="tx1">
-        <a:lumMod val="65000"/>
-        <a:lumOff val="35000"/>
-      </a:schemeClr>
-    </cs:fontRef>
-    <cs:defRPr sz="1330" kern="1200"/>
-  </cs:axisTitle>
-  <cs:categoryAxis>
-    <cs:lnRef idx="0"/>
-    <cs:fillRef idx="0"/>
-    <cs:effectRef idx="0"/>
-    <cs:fontRef idx="minor">
-      <a:schemeClr val="tx1">
-        <a:lumMod val="65000"/>
-        <a:lumOff val="35000"/>
-      </a:schemeClr>
-    </cs:fontRef>
-    <cs:spPr>
-      <a:ln w="9525" cap="flat" cmpd="sng" algn="ctr">
-        <a:solidFill>
-          <a:schemeClr val="tx1">
-            <a:lumMod val="15000"/>
-            <a:lumOff val="85000"/>
-          </a:schemeClr>
-        </a:solidFill>
-        <a:round/>
-      </a:ln>
-    </cs:spPr>
-    <cs:defRPr sz="1197" kern="1200"/>
-  </cs:categoryAxis>
-  <cs:chartArea mods="allowNoFillOverride allowNoLineOverride">
-    <cs:lnRef idx="0"/>
-    <cs:fillRef idx="0"/>
-    <cs:effectRef idx="0"/>
-    <cs:fontRef idx="minor">
-      <a:schemeClr val="tx1"/>
-    </cs:fontRef>
-    <cs:spPr>
-      <a:solidFill>
-        <a:schemeClr val="bg1"/>
-      </a:solidFill>
-      <a:ln w="9525" cap="flat" cmpd="sng" algn="ctr">
-        <a:solidFill>
-          <a:schemeClr val="tx1">
-            <a:lumMod val="15000"/>
-            <a:lumOff val="85000"/>
-          </a:schemeClr>
-        </a:solidFill>
-        <a:round/>
-      </a:ln>
-    </cs:spPr>
-    <cs:defRPr sz="1197" kern="1200"/>
-  </cs:chartArea>
-  <cs:dataLabel>
-    <cs:lnRef idx="0"/>
-    <cs:fillRef idx="0"/>
-    <cs:effectRef idx="0"/>
-    <cs:fontRef idx="minor">
-      <a:schemeClr val="tx1">
-        <a:lumMod val="75000"/>
-        <a:lumOff val="25000"/>
-      </a:schemeClr>
-    </cs:fontRef>
-    <cs:defRPr sz="1197" kern="1200"/>
-  </cs:dataLabel>
-  <cs:dataLabelCallout>
-    <cs:lnRef idx="0"/>
-    <cs:fillRef idx="0"/>
-    <cs:effectRef idx="0"/>
-    <cs:fontRef idx="minor">
-      <a:schemeClr val="dk1">
-        <a:lumMod val="65000"/>
-        <a:lumOff val="35000"/>
-      </a:schemeClr>
-    </cs:fontRef>
-    <cs:spPr>
-      <a:solidFill>
-        <a:schemeClr val="lt1"/>
-      </a:solidFill>
-      <a:ln>
-        <a:solidFill>
-          <a:schemeClr val="dk1">
-            <a:lumMod val="25000"/>
-            <a:lumOff val="75000"/>
-          </a:schemeClr>
-        </a:solidFill>
-      </a:ln>
-    </cs:spPr>
-    <cs:defRPr sz="1197" kern="1200"/>
-    <cs:bodyPr rot="0" spcFirstLastPara="1" vertOverflow="clip" horzOverflow="clip" vert="horz" wrap="square" lIns="36576" tIns="18288" rIns="36576" bIns="18288" anchor="ctr" anchorCtr="1">
-      <a:spAutoFit/>
-    </cs:bodyPr>
-  </cs:dataLabelCallout>
-  <cs:dataPoint>
-    <cs:lnRef idx="0"/>
-    <cs:fillRef idx="1">
-      <cs:styleClr val="auto"/>
-    </cs:fillRef>
-    <cs:effectRef idx="0"/>
-    <cs:fontRef idx="minor">
-      <a:schemeClr val="tx1"/>
-    </cs:fontRef>
-    <cs:spPr>
-      <a:ln w="19050">
-        <a:solidFill>
-          <a:schemeClr val="lt1"/>
-        </a:solidFill>
-      </a:ln>
-    </cs:spPr>
-  </cs:dataPoint>
-  <cs:dataPoint3D>
-    <cs:lnRef idx="0"/>
-    <cs:fillRef idx="1">
-      <cs:styleClr val="auto"/>
-    </cs:fillRef>
-    <cs:effectRef idx="0"/>
-    <cs:fontRef idx="minor">
-      <a:schemeClr val="tx1"/>
-    </cs:fontRef>
-    <cs:spPr>
-      <a:ln w="25400">
-        <a:solidFill>
-          <a:schemeClr val="lt1"/>
-        </a:solidFill>
-      </a:ln>
-    </cs:spPr>
-  </cs:dataPoint3D>
-  <cs:dataPointLine>
-    <cs:lnRef idx="0">
-      <cs:styleClr val="auto"/>
-    </cs:lnRef>
-    <cs:fillRef idx="0"/>
-    <cs:effectRef idx="0"/>
-    <cs:fontRef idx="minor">
-      <a:schemeClr val="tx1"/>
-    </cs:fontRef>
-    <cs:spPr>
-      <a:ln w="28575" cap="rnd">
-        <a:solidFill>
-          <a:schemeClr val="phClr"/>
-        </a:solidFill>
-        <a:round/>
-      </a:ln>
-    </cs:spPr>
-  </cs:dataPointLine>
-  <cs:dataPointMarker>
-    <cs:lnRef idx="0">
-      <cs:styleClr val="auto"/>
-    </cs:lnRef>
-    <cs:fillRef idx="1">
-      <cs:styleClr val="auto"/>
-    </cs:fillRef>
-    <cs:effectRef idx="0"/>
-    <cs:fontRef idx="minor">
-      <a:schemeClr val="tx1"/>
-    </cs:fontRef>
-    <cs:spPr>
-      <a:ln w="9525">
-        <a:solidFill>
-          <a:schemeClr val="phClr"/>
-        </a:solidFill>
-      </a:ln>
-    </cs:spPr>
-  </cs:dataPointMarker>
-  <cs:dataPointMarkerLayout symbol="circle" size="5"/>
-  <cs:dataPointWireframe>
-    <cs:lnRef idx="0">
-      <cs:styleClr val="auto"/>
-    </cs:lnRef>
-    <cs:fillRef idx="0"/>
-    <cs:effectRef idx="0"/>
-    <cs:fontRef idx="minor">
-      <a:schemeClr val="tx1"/>
-    </cs:fontRef>
-    <cs:spPr>
-      <a:ln w="9525" cap="rnd">
-        <a:solidFill>
-          <a:schemeClr val="phClr"/>
-        </a:solidFill>
-        <a:round/>
-      </a:ln>
-    </cs:spPr>
-  </cs:dataPointWireframe>
-  <cs:dataTable>
-    <cs:lnRef idx="0"/>
-    <cs:fillRef idx="0"/>
-    <cs:effectRef idx="0"/>
-    <cs:fontRef idx="minor">
-      <a:schemeClr val="tx1">
-        <a:lumMod val="65000"/>
-        <a:lumOff val="35000"/>
-      </a:schemeClr>
-    </cs:fontRef>
-    <cs:spPr>
-      <a:noFill/>
-      <a:ln w="9525" cap="flat" cmpd="sng" algn="ctr">
-        <a:solidFill>
-          <a:schemeClr val="tx1">
-            <a:lumMod val="15000"/>
-            <a:lumOff val="85000"/>
-          </a:schemeClr>
-        </a:solidFill>
-        <a:round/>
-      </a:ln>
-    </cs:spPr>
-    <cs:defRPr sz="1197" kern="1200"/>
-  </cs:dataTable>
-  <cs:downBar>
-    <cs:lnRef idx="0"/>
-    <cs:fillRef idx="0"/>
-    <cs:effectRef idx="0"/>
-    <cs:fontRef idx="minor">
-      <a:schemeClr val="tx1"/>
-    </cs:fontRef>
-    <cs:spPr>
-      <a:solidFill>
-        <a:schemeClr val="dk1">
-          <a:lumMod val="75000"/>
-          <a:lumOff val="25000"/>
-        </a:schemeClr>
-      </a:solidFill>
-      <a:ln w="9525" cap="flat" cmpd="sng" algn="ctr">
-        <a:solidFill>
-          <a:schemeClr val="tx1">
-            <a:lumMod val="65000"/>
-            <a:lumOff val="35000"/>
-          </a:schemeClr>
-        </a:solidFill>
-        <a:round/>
-      </a:ln>
-    </cs:spPr>
-  </cs:downBar>
-  <cs:dropLine>
-    <cs:lnRef idx="0"/>
-    <cs:fillRef idx="0"/>
-    <cs:effectRef idx="0"/>
-    <cs:fontRef idx="minor">
-      <a:schemeClr val="tx1"/>
-    </cs:fontRef>
-    <cs:spPr>
-      <a:ln w="9525" cap="flat" cmpd="sng" algn="ctr">
-        <a:solidFill>
-          <a:schemeClr val="tx1">
-            <a:lumMod val="35000"/>
-            <a:lumOff val="65000"/>
-          </a:schemeClr>
-        </a:solidFill>
-        <a:round/>
-      </a:ln>
-    </cs:spPr>
-  </cs:dropLine>
-  <cs:errorBar>
-    <cs:lnRef idx="0"/>
-    <cs:fillRef idx="0"/>
-    <cs:effectRef idx="0"/>
-    <cs:fontRef idx="minor">
-      <a:schemeClr val="tx1"/>
-    </cs:fontRef>
-    <cs:spPr>
-      <a:ln w="9525" cap="flat" cmpd="sng" algn="ctr">
-        <a:solidFill>
-          <a:schemeClr val="tx1">
-            <a:lumMod val="65000"/>
-            <a:lumOff val="35000"/>
-          </a:schemeClr>
-        </a:solidFill>
-        <a:round/>
-      </a:ln>
-    </cs:spPr>
-  </cs:errorBar>
-  <cs:floor>
-    <cs:lnRef idx="0"/>
-    <cs:fillRef idx="0"/>
-    <cs:effectRef idx="0"/>
-    <cs:fontRef idx="minor">
-      <a:schemeClr val="tx1"/>
-    </cs:fontRef>
-    <cs:spPr>
-      <a:noFill/>
-      <a:ln>
-        <a:noFill/>
-      </a:ln>
-    </cs:spPr>
-  </cs:floor>
-  <cs:gridlineMajor>
-    <cs:lnRef idx="0"/>
-    <cs:fillRef idx="0"/>
-    <cs:effectRef idx="0"/>
-    <cs:fontRef idx="minor">
-      <a:schemeClr val="tx1"/>
-    </cs:fontRef>
-    <cs:spPr>
-      <a:ln w="9525" cap="flat" cmpd="sng" algn="ctr">
-        <a:solidFill>
-          <a:schemeClr val="tx1">
-            <a:lumMod val="15000"/>
-            <a:lumOff val="85000"/>
-          </a:schemeClr>
-        </a:solidFill>
-        <a:round/>
-      </a:ln>
-    </cs:spPr>
-  </cs:gridlineMajor>
-  <cs:gridlineMinor>
-    <cs:lnRef idx="0"/>
-    <cs:fillRef idx="0"/>
-    <cs:effectRef idx="0"/>
-    <cs:fontRef idx="minor">
-      <a:schemeClr val="tx1"/>
-    </cs:fontRef>
-    <cs:spPr>
-      <a:ln w="9525" cap="flat" cmpd="sng" algn="ctr">
-        <a:solidFill>
-          <a:schemeClr val="tx1">
-            <a:lumMod val="5000"/>
-            <a:lumOff val="95000"/>
-          </a:schemeClr>
-        </a:solidFill>
-        <a:round/>
-      </a:ln>
-    </cs:spPr>
-  </cs:gridlineMinor>
-  <cs:hiLoLine>
-    <cs:lnRef idx="0"/>
-    <cs:fillRef idx="0"/>
-    <cs:effectRef idx="0"/>
-    <cs:fontRef idx="minor">
-      <a:schemeClr val="tx1"/>
-    </cs:fontRef>
-    <cs:spPr>
-      <a:ln w="9525" cap="flat" cmpd="sng" algn="ctr">
-        <a:solidFill>
-          <a:schemeClr val="tx1">
-            <a:lumMod val="50000"/>
-            <a:lumOff val="50000"/>
-          </a:schemeClr>
-        </a:solidFill>
-        <a:round/>
-      </a:ln>
-    </cs:spPr>
-  </cs:hiLoLine>
-  <cs:leaderLine>
-    <cs:lnRef idx="0"/>
-    <cs:fillRef idx="0"/>
-    <cs:effectRef idx="0"/>
-    <cs:fontRef idx="minor">
-      <a:schemeClr val="tx1"/>
-    </cs:fontRef>
-    <cs:spPr>
-      <a:ln w="9525" cap="flat" cmpd="sng" algn="ctr">
-        <a:solidFill>
-          <a:schemeClr val="tx1">
-            <a:lumMod val="35000"/>
-            <a:lumOff val="65000"/>
-          </a:schemeClr>
-        </a:solidFill>
-        <a:round/>
-      </a:ln>
-    </cs:spPr>
-  </cs:leaderLine>
-  <cs:legend>
-    <cs:lnRef idx="0"/>
-    <cs:fillRef idx="0"/>
-    <cs:effectRef idx="0"/>
-    <cs:fontRef idx="minor">
-      <a:schemeClr val="tx1">
-        <a:lumMod val="65000"/>
-        <a:lumOff val="35000"/>
-      </a:schemeClr>
-    </cs:fontRef>
-    <cs:defRPr sz="1197" kern="1200"/>
-  </cs:legend>
-  <cs:plotArea mods="allowNoFillOverride allowNoLineOverride">
-    <cs:lnRef idx="0"/>
-    <cs:fillRef idx="0"/>
-    <cs:effectRef idx="0"/>
-    <cs:fontRef idx="minor">
-      <a:schemeClr val="tx1"/>
-    </cs:fontRef>
-  </cs:plotArea>
-  <cs:plotArea3D mods="allowNoFillOverride allowNoLineOverride">
-    <cs:lnRef idx="0"/>
-    <cs:fillRef idx="0"/>
-    <cs:effectRef idx="0"/>
-    <cs:fontRef idx="minor">
-      <a:schemeClr val="tx1"/>
-    </cs:fontRef>
-  </cs:plotArea3D>
-  <cs:seriesAxis>
-    <cs:lnRef idx="0"/>
-    <cs:fillRef idx="0"/>
-    <cs:effectRef idx="0"/>
-    <cs:fontRef idx="minor">
-      <a:schemeClr val="tx1">
-        <a:lumMod val="65000"/>
-        <a:lumOff val="35000"/>
-      </a:schemeClr>
-    </cs:fontRef>
-    <cs:defRPr sz="1197" kern="1200"/>
-  </cs:seriesAxis>
-  <cs:seriesLine>
-    <cs:lnRef idx="0"/>
-    <cs:fillRef idx="0"/>
-    <cs:effectRef idx="0"/>
-    <cs:fontRef idx="minor">
-      <a:schemeClr val="tx1"/>
-    </cs:fontRef>
-    <cs:spPr>
-      <a:ln w="9525" cap="flat" cmpd="sng" algn="ctr">
-        <a:solidFill>
-          <a:schemeClr val="tx1">
-            <a:lumMod val="35000"/>
-            <a:lumOff val="65000"/>
-          </a:schemeClr>
-        </a:solidFill>
-        <a:round/>
-      </a:ln>
-    </cs:spPr>
-  </cs:seriesLine>
-  <cs:title>
-    <cs:lnRef idx="0"/>
-    <cs:fillRef idx="0"/>
-    <cs:effectRef idx="0"/>
-    <cs:fontRef idx="minor">
-      <a:schemeClr val="tx1">
-        <a:lumMod val="65000"/>
-        <a:lumOff val="35000"/>
-      </a:schemeClr>
-    </cs:fontRef>
-    <cs:defRPr sz="1862" b="0" kern="1200" spc="0" baseline="0"/>
-  </cs:title>
-  <cs:trendline>
-    <cs:lnRef idx="0">
-      <cs:styleClr val="auto"/>
-    </cs:lnRef>
-    <cs:fillRef idx="0"/>
-    <cs:effectRef idx="0"/>
-    <cs:fontRef idx="minor">
-      <a:schemeClr val="tx1"/>
-    </cs:fontRef>
-    <cs:spPr>
-      <a:ln w="19050" cap="rnd">
-        <a:solidFill>
-          <a:schemeClr val="phClr"/>
-        </a:solidFill>
-        <a:prstDash val="sysDot"/>
-      </a:ln>
-    </cs:spPr>
-  </cs:trendline>
-  <cs:trendlineLabel>
-    <cs:lnRef idx="0"/>
-    <cs:fillRef idx="0"/>
-    <cs:effectRef idx="0"/>
-    <cs:fontRef idx="minor">
-      <a:schemeClr val="tx1">
-        <a:lumMod val="65000"/>
-        <a:lumOff val="35000"/>
-      </a:schemeClr>
-    </cs:fontRef>
-    <cs:defRPr sz="1197" kern="1200"/>
-  </cs:trendlineLabel>
-  <cs:upBar>
-    <cs:lnRef idx="0"/>
-    <cs:fillRef idx="0"/>
-    <cs:effectRef idx="0"/>
-    <cs:fontRef idx="minor">
-      <a:schemeClr val="tx1"/>
-    </cs:fontRef>
-    <cs:spPr>
-      <a:solidFill>
-        <a:schemeClr val="lt1"/>
-      </a:solidFill>
-      <a:ln w="9525" cap="flat" cmpd="sng" algn="ctr">
-        <a:solidFill>
-          <a:schemeClr val="tx1">
-            <a:lumMod val="65000"/>
-            <a:lumOff val="35000"/>
-          </a:schemeClr>
-        </a:solidFill>
-        <a:round/>
-      </a:ln>
-    </cs:spPr>
-  </cs:upBar>
-  <cs:valueAxis>
-    <cs:lnRef idx="0"/>
-    <cs:fillRef idx="0"/>
-    <cs:effectRef idx="0"/>
-    <cs:fontRef idx="minor">
-      <a:schemeClr val="tx1">
-        <a:lumMod val="65000"/>
-        <a:lumOff val="35000"/>
-      </a:schemeClr>
-    </cs:fontRef>
-    <cs:defRPr sz="1197" kern="1200"/>
-  </cs:valueAxis>
-  <cs:wall>
-    <cs:lnRef idx="0"/>
-    <cs:fillRef idx="0"/>
-    <cs:effectRef idx="0"/>
-    <cs:fontRef idx="minor">
-      <a:schemeClr val="tx1"/>
-    </cs:fontRef>
-    <cs:spPr>
-      <a:noFill/>
-      <a:ln>
-        <a:noFill/>
-      </a:ln>
-    </cs:spPr>
-  </cs:wall>
-</cs:chartStyle>
-</file>
-
 <file path=ppt/handoutMasters/handoutMaster1.xml><?xml version="1.0" encoding="utf-8"?>
 <p:handoutMaster xmlns:a="http://schemas.openxmlformats.org/drawingml/2006/main" xmlns:r="http://schemas.openxmlformats.org/officeDocument/2006/relationships" xmlns:p="http://schemas.openxmlformats.org/presentationml/2006/main">
   <p:cSld>
@@ -2026,7 +1255,7 @@
           <a:p>
             <a:fld id="{E2FE77E8-BC33-C74B-9CC2-F4DA69E5A52A}" type="datetimeFigureOut">
               <a:rPr lang="en-US" smtClean="0"/>
-              <a:t>3/17/26</a:t>
+              <a:t>4/19/26</a:t>
             </a:fld>
             <a:endParaRPr lang="en-US"/>
           </a:p>
@@ -4309,7 +3538,7 @@
             <a:fld id="{E54BFB26-65E8-0746-AE1F-BB6A120F4B8F}" type="datetimeFigureOut">
               <a:rPr lang="en-US" smtClean="0"/>
               <a:pPr/>
-              <a:t>3/17/26</a:t>
+              <a:t>4/19/26</a:t>
             </a:fld>
             <a:endParaRPr lang="en-US" dirty="0"/>
           </a:p>
@@ -4813,8 +4042,8 @@
         </p:nvSpPr>
         <p:spPr>
           <a:xfrm>
-            <a:off x="1323974" y="6468137"/>
-            <a:ext cx="12929836" cy="12216056"/>
+            <a:off x="1323974" y="6468136"/>
+            <a:ext cx="12929836" cy="13927871"/>
           </a:xfrm>
           <a:prstGeom prst="rect">
             <a:avLst/>
@@ -4847,11 +4076,14 @@
           <a:lstStyle/>
           <a:p>
             <a:pPr algn="ctr"/>
-            <a:endParaRPr lang="en-US" dirty="0">
-              <a:solidFill>
-                <a:srgbClr val="271E3D"/>
-              </a:solidFill>
-            </a:endParaRPr>
+            <a:r>
+              <a:rPr lang="en-US" dirty="0">
+                <a:solidFill>
+                  <a:srgbClr val="271E3D"/>
+                </a:solidFill>
+              </a:rPr>
+              <a:t>	 	</a:t>
+            </a:r>
           </a:p>
         </p:txBody>
       </p:sp>
@@ -5074,206 +4306,6 @@
       </p:sp>
       <p:sp>
         <p:nvSpPr>
-          <p:cNvPr id="8" name="Picture Placeholder 25">
-            <a:extLst>
-              <a:ext uri="{FF2B5EF4-FFF2-40B4-BE49-F238E27FC236}">
-                <a16:creationId xmlns:a16="http://schemas.microsoft.com/office/drawing/2014/main" id="{4AFFA821-268F-75F3-3070-60004F0C3476}"/>
-              </a:ext>
-            </a:extLst>
-          </p:cNvPr>
-          <p:cNvSpPr txBox="1">
-            <a:spLocks/>
-          </p:cNvSpPr>
-          <p:nvPr/>
-        </p:nvSpPr>
-        <p:spPr>
-          <a:xfrm>
-            <a:off x="1747838" y="11391158"/>
-            <a:ext cx="11841938" cy="6209114"/>
-          </a:xfrm>
-          <a:prstGeom prst="rect">
-            <a:avLst/>
-          </a:prstGeom>
-          <a:solidFill>
-            <a:srgbClr val="A4A0AE"/>
-          </a:solidFill>
-        </p:spPr>
-        <p:txBody>
-          <a:bodyPr anchor="ctr"/>
-          <a:lstStyle>
-            <a:lvl1pPr marL="0" indent="0" algn="ctr" defTabSz="1950836" rtl="0" eaLnBrk="1" latinLnBrk="0" hangingPunct="1">
-              <a:lnSpc>
-                <a:spcPct val="90000"/>
-              </a:lnSpc>
-              <a:spcBef>
-                <a:spcPts val="2134"/>
-              </a:spcBef>
-              <a:buFont typeface="Arial" panose="020B0604020202020204" pitchFamily="34" charset="0"/>
-              <a:buNone/>
-              <a:defRPr sz="5972" b="0" i="0" kern="1200">
-                <a:solidFill>
-                  <a:schemeClr val="tx1"/>
-                </a:solidFill>
-                <a:latin typeface="+mn-lt"/>
-                <a:ea typeface="+mn-ea"/>
-                <a:cs typeface="+mn-cs"/>
-              </a:defRPr>
-            </a:lvl1pPr>
-            <a:lvl2pPr marL="1463128" indent="-487711" algn="l" defTabSz="1950836" rtl="0" eaLnBrk="1" latinLnBrk="0" hangingPunct="1">
-              <a:lnSpc>
-                <a:spcPct val="90000"/>
-              </a:lnSpc>
-              <a:spcBef>
-                <a:spcPts val="1067"/>
-              </a:spcBef>
-              <a:buFont typeface="Arial" panose="020B0604020202020204" pitchFamily="34" charset="0"/>
-              <a:buChar char="•"/>
-              <a:defRPr sz="5119" b="0" i="0" kern="1200">
-                <a:solidFill>
-                  <a:schemeClr val="tx1"/>
-                </a:solidFill>
-                <a:latin typeface="+mn-lt"/>
-                <a:ea typeface="+mn-ea"/>
-                <a:cs typeface="+mn-cs"/>
-              </a:defRPr>
-            </a:lvl2pPr>
-            <a:lvl3pPr marL="2438547" indent="-487711" algn="l" defTabSz="1950836" rtl="0" eaLnBrk="1" latinLnBrk="0" hangingPunct="1">
-              <a:lnSpc>
-                <a:spcPct val="90000"/>
-              </a:lnSpc>
-              <a:spcBef>
-                <a:spcPts val="1067"/>
-              </a:spcBef>
-              <a:buFont typeface="Arial" panose="020B0604020202020204" pitchFamily="34" charset="0"/>
-              <a:buChar char="•"/>
-              <a:defRPr sz="4266" b="0" i="0" kern="1200">
-                <a:solidFill>
-                  <a:schemeClr val="tx1"/>
-                </a:solidFill>
-                <a:latin typeface="+mn-lt"/>
-                <a:ea typeface="+mn-ea"/>
-                <a:cs typeface="+mn-cs"/>
-              </a:defRPr>
-            </a:lvl3pPr>
-            <a:lvl4pPr marL="3413965" indent="-487711" algn="l" defTabSz="1950836" rtl="0" eaLnBrk="1" latinLnBrk="0" hangingPunct="1">
-              <a:lnSpc>
-                <a:spcPct val="90000"/>
-              </a:lnSpc>
-              <a:spcBef>
-                <a:spcPts val="1067"/>
-              </a:spcBef>
-              <a:buFont typeface="Arial" panose="020B0604020202020204" pitchFamily="34" charset="0"/>
-              <a:buChar char="•"/>
-              <a:defRPr sz="3838" b="0" i="0" kern="1200">
-                <a:solidFill>
-                  <a:schemeClr val="tx1"/>
-                </a:solidFill>
-                <a:latin typeface="+mn-lt"/>
-                <a:ea typeface="+mn-ea"/>
-                <a:cs typeface="+mn-cs"/>
-              </a:defRPr>
-            </a:lvl4pPr>
-            <a:lvl5pPr marL="4389381" indent="-487711" algn="l" defTabSz="1950836" rtl="0" eaLnBrk="1" latinLnBrk="0" hangingPunct="1">
-              <a:lnSpc>
-                <a:spcPct val="90000"/>
-              </a:lnSpc>
-              <a:spcBef>
-                <a:spcPts val="1067"/>
-              </a:spcBef>
-              <a:buFont typeface="Arial" panose="020B0604020202020204" pitchFamily="34" charset="0"/>
-              <a:buChar char="•"/>
-              <a:defRPr sz="3838" b="0" i="0" kern="1200">
-                <a:solidFill>
-                  <a:schemeClr val="tx1"/>
-                </a:solidFill>
-                <a:latin typeface="+mn-lt"/>
-                <a:ea typeface="+mn-ea"/>
-                <a:cs typeface="+mn-cs"/>
-              </a:defRPr>
-            </a:lvl5pPr>
-            <a:lvl6pPr marL="5364800" indent="-487711" algn="l" defTabSz="1950836" rtl="0" eaLnBrk="1" latinLnBrk="0" hangingPunct="1">
-              <a:lnSpc>
-                <a:spcPct val="90000"/>
-              </a:lnSpc>
-              <a:spcBef>
-                <a:spcPts val="1067"/>
-              </a:spcBef>
-              <a:buFont typeface="Arial" panose="020B0604020202020204" pitchFamily="34" charset="0"/>
-              <a:buChar char="•"/>
-              <a:defRPr sz="3838" kern="1200">
-                <a:solidFill>
-                  <a:schemeClr val="tx1"/>
-                </a:solidFill>
-                <a:latin typeface="+mn-lt"/>
-                <a:ea typeface="+mn-ea"/>
-                <a:cs typeface="+mn-cs"/>
-              </a:defRPr>
-            </a:lvl6pPr>
-            <a:lvl7pPr marL="6340220" indent="-487711" algn="l" defTabSz="1950836" rtl="0" eaLnBrk="1" latinLnBrk="0" hangingPunct="1">
-              <a:lnSpc>
-                <a:spcPct val="90000"/>
-              </a:lnSpc>
-              <a:spcBef>
-                <a:spcPts val="1067"/>
-              </a:spcBef>
-              <a:buFont typeface="Arial" panose="020B0604020202020204" pitchFamily="34" charset="0"/>
-              <a:buChar char="•"/>
-              <a:defRPr sz="3838" kern="1200">
-                <a:solidFill>
-                  <a:schemeClr val="tx1"/>
-                </a:solidFill>
-                <a:latin typeface="+mn-lt"/>
-                <a:ea typeface="+mn-ea"/>
-                <a:cs typeface="+mn-cs"/>
-              </a:defRPr>
-            </a:lvl7pPr>
-            <a:lvl8pPr marL="7315639" indent="-487711" algn="l" defTabSz="1950836" rtl="0" eaLnBrk="1" latinLnBrk="0" hangingPunct="1">
-              <a:lnSpc>
-                <a:spcPct val="90000"/>
-              </a:lnSpc>
-              <a:spcBef>
-                <a:spcPts val="1067"/>
-              </a:spcBef>
-              <a:buFont typeface="Arial" panose="020B0604020202020204" pitchFamily="34" charset="0"/>
-              <a:buChar char="•"/>
-              <a:defRPr sz="3838" kern="1200">
-                <a:solidFill>
-                  <a:schemeClr val="tx1"/>
-                </a:solidFill>
-                <a:latin typeface="+mn-lt"/>
-                <a:ea typeface="+mn-ea"/>
-                <a:cs typeface="+mn-cs"/>
-              </a:defRPr>
-            </a:lvl8pPr>
-            <a:lvl9pPr marL="8291055" indent="-487711" algn="l" defTabSz="1950836" rtl="0" eaLnBrk="1" latinLnBrk="0" hangingPunct="1">
-              <a:lnSpc>
-                <a:spcPct val="90000"/>
-              </a:lnSpc>
-              <a:spcBef>
-                <a:spcPts val="1067"/>
-              </a:spcBef>
-              <a:buFont typeface="Arial" panose="020B0604020202020204" pitchFamily="34" charset="0"/>
-              <a:buChar char="•"/>
-              <a:defRPr sz="3838" kern="1200">
-                <a:solidFill>
-                  <a:schemeClr val="tx1"/>
-                </a:solidFill>
-                <a:latin typeface="+mn-lt"/>
-                <a:ea typeface="+mn-ea"/>
-                <a:cs typeface="+mn-cs"/>
-              </a:defRPr>
-            </a:lvl9pPr>
-          </a:lstStyle>
-          <a:p>
-            <a:r>
-              <a:rPr lang="en-US" dirty="0"/>
-              <a:t>Insert your image here</a:t>
-            </a:r>
-          </a:p>
-        </p:txBody>
-      </p:sp>
-      <p:sp>
-        <p:nvSpPr>
           <p:cNvPr id="9" name="Text Placeholder 35">
             <a:extLst>
               <a:ext uri="{FF2B5EF4-FFF2-40B4-BE49-F238E27FC236}">
@@ -5289,7 +4321,7 @@
         <p:spPr>
           <a:xfrm>
             <a:off x="1863725" y="7820465"/>
-            <a:ext cx="11726051" cy="6209114"/>
+            <a:ext cx="11726051" cy="3981549"/>
           </a:xfrm>
           <a:prstGeom prst="rect">
             <a:avLst/>
@@ -5465,36 +4497,61 @@
           </a:lstStyle>
           <a:p>
             <a:r>
-              <a:rPr lang="en-GB" dirty="0">
+              <a:rPr lang="en-GB" sz="4000" b="1" dirty="0">
                 <a:solidFill>
                   <a:schemeClr val="tx1"/>
                 </a:solidFill>
               </a:rPr>
-              <a:t>Fake news spreads rapidly on social media and can influence public opinion, health behaviour, and trust in institutions.</a:t>
+              <a:t>Why multimodal?</a:t>
             </a:r>
           </a:p>
           <a:p>
-            <a:r>
+            <a:br>
               <a:rPr lang="en-GB" dirty="0">
                 <a:solidFill>
                   <a:schemeClr val="tx1"/>
                 </a:solidFill>
               </a:rPr>
-              <a:t>Most existing detection approaches focus on text only, while real online posts combine text and images.</a:t>
-            </a:r>
-          </a:p>
-          <a:p>
+            </a:br>
             <a:r>
               <a:rPr lang="en-GB" dirty="0">
                 <a:solidFill>
                   <a:schemeClr val="tx1"/>
                 </a:solidFill>
               </a:rPr>
-              <a:t>This project investigates whether combining both modalities can improve fake news detection robustness</a:t>
-            </a:r>
-            <a:r>
-              <a:rPr lang="en-GB" dirty="0"/>
-              <a:t>.</a:t>
+              <a:t>Misinformation on social platforms often appears as </a:t>
+            </a:r>
+            <a:r>
+              <a:rPr lang="en-GB" b="1" dirty="0">
+                <a:solidFill>
+                  <a:schemeClr val="tx1"/>
+                </a:solidFill>
+              </a:rPr>
+              <a:t>posts with both text and images</a:t>
+            </a:r>
+            <a:r>
+              <a:rPr lang="en-GB" dirty="0">
+                <a:solidFill>
+                  <a:schemeClr val="tx1"/>
+                </a:solidFill>
+              </a:rPr>
+              <a:t>. Text-only detectors miss visual cues; image-only models ignore claims and context. This work asks whether </a:t>
+            </a:r>
+            <a:r>
+              <a:rPr lang="en-GB" b="1" dirty="0">
+                <a:solidFill>
+                  <a:schemeClr val="tx1"/>
+                </a:solidFill>
+              </a:rPr>
+              <a:t>joint use of text and image</a:t>
+            </a:r>
+            <a:r>
+              <a:rPr lang="en-GB" dirty="0">
+                <a:solidFill>
+                  <a:schemeClr val="tx1"/>
+                </a:solidFill>
+              </a:rPr>
+              <a:t> can support more robust detection than single-modality baselines, in line with gaps noted in the literature (controlled fusion comparisons, cost reporting, practical evaluation).</a:t>
             </a:r>
           </a:p>
         </p:txBody>
@@ -5515,7 +4572,7 @@
         </p:nvSpPr>
         <p:spPr>
           <a:xfrm>
-            <a:off x="1293811" y="19498510"/>
+            <a:off x="1545792" y="21154425"/>
             <a:ext cx="13283950" cy="970985"/>
           </a:xfrm>
           <a:prstGeom prst="rect">
@@ -5721,7 +4778,7 @@
         </p:nvSpPr>
         <p:spPr>
           <a:xfrm>
-            <a:off x="1304498" y="20764110"/>
+            <a:off x="1512991" y="22501717"/>
             <a:ext cx="13284199" cy="5586605"/>
           </a:xfrm>
           <a:prstGeom prst="rect">
@@ -5903,36 +4960,21 @@
             </a:lvl9pPr>
           </a:lstStyle>
           <a:p>
-            <a:pPr indent="-487711">
-              <a:buFont typeface="Arial" panose="020B0604020202020204" pitchFamily="34" charset="0"/>
-              <a:buChar char="•"/>
-              <a:defRPr/>
-            </a:pPr>
+            <a:r>
+              <a:rPr lang="en-GB" b="1" dirty="0"/>
+              <a:t>RQ1:</a:t>
+            </a:r>
             <a:r>
               <a:rPr lang="en-GB" dirty="0"/>
-              <a:t>Text text text text text text text text text text text text text text text</a:t>
-            </a:r>
-          </a:p>
-          <a:p>
-            <a:pPr indent="-487711">
-              <a:buFont typeface="Arial" panose="020B0604020202020204" pitchFamily="34" charset="0"/>
-              <a:buChar char="•"/>
-              <a:defRPr/>
-            </a:pPr>
+              <a:t> Transfer learning vs traditional ML — effectiveness and </a:t>
+            </a:r>
+            <a:r>
+              <a:rPr lang="en-GB" b="1" dirty="0"/>
+              <a:t>computational cost</a:t>
+            </a:r>
             <a:r>
               <a:rPr lang="en-GB" dirty="0"/>
-              <a:t>Text text text text text text text text text</a:t>
-            </a:r>
-          </a:p>
-          <a:p>
-            <a:pPr indent="-487711">
-              <a:buFont typeface="Arial" panose="020B0604020202020204" pitchFamily="34" charset="0"/>
-              <a:buChar char="•"/>
-              <a:defRPr/>
-            </a:pPr>
-            <a:r>
-              <a:rPr lang="en-GB" dirty="0"/>
-              <a:t>Text text text text text text text text text text text text</a:t>
+              <a:t>.</a:t>
             </a:r>
           </a:p>
           <a:p>
@@ -5940,8 +4982,57 @@
           </a:p>
           <a:p>
             <a:r>
+              <a:rPr lang="en-GB" b="1" dirty="0"/>
+              <a:t>RQ2:</a:t>
+            </a:r>
+            <a:r>
               <a:rPr lang="en-GB" dirty="0"/>
-              <a:t>Text text text text text text text text text text text text text text text text text text text text text text text text text text text text text text text text text text text text text text text text text text text text text text text text text text text text text text text text text text text text.</a:t>
+              <a:t> </a:t>
+            </a:r>
+            <a:r>
+              <a:rPr lang="en-GB" b="1" dirty="0"/>
+              <a:t>Fusion mechanisms</a:t>
+            </a:r>
+            <a:r>
+              <a:rPr lang="en-GB" dirty="0"/>
+              <a:t> (e.g. early vs late vs attention-based) under comparable settings.</a:t>
+            </a:r>
+          </a:p>
+          <a:p>
+            <a:endParaRPr lang="en-GB" dirty="0"/>
+          </a:p>
+          <a:p>
+            <a:r>
+              <a:rPr lang="en-GB" b="1" dirty="0"/>
+              <a:t>RQ3:</a:t>
+            </a:r>
+            <a:r>
+              <a:rPr lang="en-GB" dirty="0"/>
+              <a:t> </a:t>
+            </a:r>
+            <a:r>
+              <a:rPr lang="en-GB" b="1" dirty="0"/>
+              <a:t>Multimodal vs unimodal</a:t>
+            </a:r>
+            <a:r>
+              <a:rPr lang="en-GB" dirty="0"/>
+              <a:t> gains across content types.</a:t>
+            </a:r>
+          </a:p>
+          <a:p>
+            <a:r>
+              <a:rPr lang="en-GB" b="1" dirty="0"/>
+              <a:t>Scope:</a:t>
+            </a:r>
+            <a:r>
+              <a:rPr lang="en-GB" dirty="0"/>
+              <a:t> Text + image only; video/audio out of scope.</a:t>
+            </a:r>
+          </a:p>
+          <a:p>
+            <a:r>
+              <a:rPr lang="en-GB" dirty="0"/>
+              <a:t>text text text text text text text text text text text text text text.</a:t>
             </a:r>
           </a:p>
           <a:p>
@@ -6172,7 +5263,7 @@
         <p:spPr>
           <a:xfrm>
             <a:off x="15094757" y="7767986"/>
-            <a:ext cx="12780962" cy="10916207"/>
+            <a:ext cx="12780962" cy="11282014"/>
           </a:xfrm>
           <a:prstGeom prst="rect">
             <a:avLst/>
@@ -6353,34 +5444,204 @@
             </a:lvl9pPr>
           </a:lstStyle>
           <a:p>
-            <a:pPr>
-              <a:defRPr/>
-            </a:pPr>
-            <a:r>
-              <a:rPr lang="en-GB" dirty="0"/>
-              <a:t>Primary Sources – </a:t>
-            </a:r>
-            <a:r>
-              <a:rPr lang="en-GB" dirty="0" err="1"/>
-              <a:t>FakeNewsNet</a:t>
-            </a:r>
-            <a:r>
-              <a:rPr lang="en-GB" dirty="0"/>
-              <a:t> , </a:t>
-            </a:r>
-            <a:r>
-              <a:rPr lang="en-GB" dirty="0" err="1"/>
-              <a:t>Fakedit</a:t>
-            </a:r>
-            <a:endParaRPr lang="en-GB" dirty="0"/>
+            <a:r>
+              <a:rPr lang="en-GB" sz="3600" b="1" dirty="0"/>
+              <a:t>Sources</a:t>
+            </a:r>
+            <a:endParaRPr lang="en-GB" sz="3600" dirty="0"/>
           </a:p>
           <a:p>
-            <a:pPr>
-              <a:defRPr/>
-            </a:pPr>
+            <a:r>
+              <a:rPr lang="en-GB" b="1" dirty="0" err="1"/>
+              <a:t>FakeNewsNet</a:t>
+            </a:r>
             <a:r>
               <a:rPr lang="en-GB" dirty="0"/>
-              <a:t>Publicly available – contain image and text modalities</a:t>
+              <a:t> (e.g. PolitiFact / </a:t>
+            </a:r>
+            <a:r>
+              <a:rPr lang="en-GB" dirty="0" err="1"/>
+              <a:t>GossipCop</a:t>
+            </a:r>
+            <a:r>
+              <a:rPr lang="en-GB" dirty="0"/>
+              <a:t>): news articles with crawled text and images.</a:t>
+            </a:r>
+          </a:p>
+          <a:p>
+            <a:r>
+              <a:rPr lang="en-GB" b="1" dirty="0" err="1"/>
+              <a:t>Fakeddit</a:t>
+            </a:r>
+            <a:r>
+              <a:rPr lang="en-GB" dirty="0"/>
+              <a:t> (Reddit): multimodal posts with metadata and image URLs.</a:t>
+            </a:r>
+          </a:p>
+          <a:p>
+            <a:r>
+              <a:rPr lang="en-GB" sz="4000" b="1" dirty="0"/>
+              <a:t>High-level processing pipeline</a:t>
+            </a:r>
+            <a:endParaRPr lang="en-GB" sz="4000" dirty="0"/>
+          </a:p>
+          <a:p>
+            <a:r>
+              <a:rPr lang="en-GB" b="1" dirty="0"/>
+              <a:t>Acquire</a:t>
+            </a:r>
+            <a:r>
+              <a:rPr lang="en-GB" dirty="0"/>
+              <a:t> — crawl / download sources (01–02).</a:t>
+            </a:r>
+          </a:p>
+          <a:p>
+            <a:r>
+              <a:rPr lang="en-GB" b="1" dirty="0"/>
+              <a:t>Unify</a:t>
+            </a:r>
+            <a:r>
+              <a:rPr lang="en-GB" dirty="0"/>
+              <a:t> — single </a:t>
+            </a:r>
+            <a:r>
+              <a:rPr lang="en-GB" b="1" dirty="0"/>
+              <a:t>tabular schema</a:t>
+            </a:r>
+            <a:r>
+              <a:rPr lang="en-GB" dirty="0"/>
+              <a:t> (04): </a:t>
+            </a:r>
+            <a:r>
+              <a:rPr lang="en-GB" dirty="0" err="1"/>
+              <a:t>fakenews.tsv</a:t>
+            </a:r>
+            <a:r>
+              <a:rPr lang="en-GB" dirty="0"/>
+              <a:t>.</a:t>
+            </a:r>
+          </a:p>
+          <a:p>
+            <a:r>
+              <a:rPr lang="en-GB" b="1" dirty="0"/>
+              <a:t>Cohort</a:t>
+            </a:r>
+            <a:r>
+              <a:rPr lang="en-GB" dirty="0"/>
+              <a:t> — stratified </a:t>
+            </a:r>
+            <a:r>
+              <a:rPr lang="en-GB" b="1" dirty="0"/>
+              <a:t>multimodal plan</a:t>
+            </a:r>
+            <a:r>
+              <a:rPr lang="en-GB" dirty="0"/>
+              <a:t> (05); </a:t>
+            </a:r>
+            <a:r>
+              <a:rPr lang="en-GB" b="1" dirty="0"/>
+              <a:t>download images</a:t>
+            </a:r>
+            <a:r>
+              <a:rPr lang="en-GB" dirty="0"/>
+              <a:t> (06); optional </a:t>
+            </a:r>
+            <a:r>
+              <a:rPr lang="en-GB" b="1" dirty="0"/>
+              <a:t>log dedupe</a:t>
+            </a:r>
+            <a:r>
+              <a:rPr lang="en-GB" dirty="0"/>
+              <a:t> (07).</a:t>
+            </a:r>
+          </a:p>
+          <a:p>
+            <a:r>
+              <a:rPr lang="en-GB" b="1" dirty="0"/>
+              <a:t>Quality gate</a:t>
+            </a:r>
+            <a:r>
+              <a:rPr lang="en-GB" dirty="0"/>
+              <a:t> — </a:t>
+            </a:r>
+            <a:r>
+              <a:rPr lang="en-GB" b="1" dirty="0"/>
+              <a:t>heuristic image validity</a:t>
+            </a:r>
+            <a:r>
+              <a:rPr lang="en-GB" dirty="0"/>
+              <a:t> score (08); merge into table (09–10).</a:t>
+            </a:r>
+          </a:p>
+          <a:p>
+            <a:r>
+              <a:rPr lang="en-GB" b="1" dirty="0"/>
+              <a:t>Gated export</a:t>
+            </a:r>
+            <a:r>
+              <a:rPr lang="en-GB" dirty="0"/>
+              <a:t> — training-facing subset </a:t>
+            </a:r>
+            <a:r>
+              <a:rPr lang="en-GB" b="1" dirty="0" err="1"/>
+              <a:t>fake_news_final.tsv</a:t>
+            </a:r>
+            <a:r>
+              <a:rPr lang="en-GB" dirty="0"/>
+              <a:t> (11, score threshold e.g. ≥75).</a:t>
+            </a:r>
+          </a:p>
+          <a:p>
+            <a:endParaRPr lang="en-GB" b="1" dirty="0"/>
+          </a:p>
+          <a:p>
+            <a:r>
+              <a:rPr lang="en-GB" b="1" dirty="0"/>
+              <a:t>Current status </a:t>
+            </a:r>
+          </a:p>
+          <a:p>
+            <a:r>
+              <a:rPr lang="en-GB" dirty="0"/>
+              <a:t>Gated multimodal export: </a:t>
+            </a:r>
+            <a:r>
+              <a:rPr lang="en-GB" b="1" dirty="0"/>
+              <a:t>≈49k rows</a:t>
+            </a:r>
+            <a:r>
+              <a:rPr lang="en-GB" dirty="0"/>
+              <a:t> in </a:t>
+            </a:r>
+            <a:r>
+              <a:rPr lang="en-GB" dirty="0" err="1"/>
+              <a:t>fake_news_final.tsv</a:t>
+            </a:r>
+            <a:r>
+              <a:rPr lang="en-GB" dirty="0"/>
+              <a:t> (check splits/labels in notebook).</a:t>
+            </a:r>
+          </a:p>
+          <a:p>
+            <a:r>
+              <a:rPr lang="en-GB" dirty="0"/>
+              <a:t>Reproducible </a:t>
+            </a:r>
+            <a:r>
+              <a:rPr lang="en-GB" b="1" dirty="0"/>
+              <a:t>Python pipeline</a:t>
+            </a:r>
+            <a:r>
+              <a:rPr lang="en-GB" dirty="0"/>
+              <a:t> + </a:t>
+            </a:r>
+            <a:r>
+              <a:rPr lang="en-GB" b="1" dirty="0"/>
+              <a:t>EDA / QA notebook</a:t>
+            </a:r>
+            <a:r>
+              <a:rPr lang="en-GB" dirty="0"/>
+              <a:t> for profiling.</a:t>
             </a:r>
           </a:p>
           <a:p>
@@ -6388,15 +5649,6 @@
               <a:defRPr/>
             </a:pPr>
             <a:endParaRPr lang="en-GB" dirty="0"/>
-          </a:p>
-          <a:p>
-            <a:pPr>
-              <a:defRPr/>
-            </a:pPr>
-            <a:r>
-              <a:rPr lang="en-GB" dirty="0"/>
-              <a:t> </a:t>
-            </a:r>
           </a:p>
           <a:p>
             <a:pPr>
@@ -6865,12 +6117,47 @@
             </a:lvl9pPr>
           </a:lstStyle>
           <a:p>
-            <a:pPr>
-              <a:defRPr/>
-            </a:pPr>
             <a:r>
               <a:rPr lang="en-GB" dirty="0"/>
-              <a:t>Text text text text text text text text text text text text text text text text text text text text text text text text text text text text text text text text text text text text text text text text text text text text text text text text text text text text text text text text text text text text text text text text text text text text text text text text text text text text text text text text text text text text text text text text text text text text text text text text text text text text text text text text text text text text.</a:t>
+              <a:t>A </a:t>
+            </a:r>
+            <a:r>
+              <a:rPr lang="en-GB" b="1" dirty="0"/>
+              <a:t>clear, reproducible data path</a:t>
+            </a:r>
+            <a:r>
+              <a:rPr lang="en-GB" dirty="0"/>
+              <a:t> from raw sources to a </a:t>
+            </a:r>
+            <a:r>
+              <a:rPr lang="en-GB" b="1" dirty="0"/>
+              <a:t>gated multimodal cohort</a:t>
+            </a:r>
+            <a:r>
+              <a:rPr lang="en-GB" dirty="0"/>
+              <a:t>.</a:t>
+            </a:r>
+          </a:p>
+          <a:p>
+            <a:r>
+              <a:rPr lang="en-GB" dirty="0"/>
+              <a:t>Empirical comparison of </a:t>
+            </a:r>
+            <a:r>
+              <a:rPr lang="en-GB" b="1" dirty="0"/>
+              <a:t>fusion strategies</a:t>
+            </a:r>
+            <a:r>
+              <a:rPr lang="en-GB" dirty="0"/>
+              <a:t> and </a:t>
+            </a:r>
+            <a:r>
+              <a:rPr lang="en-GB" b="1" dirty="0"/>
+              <a:t>modality combinations</a:t>
+            </a:r>
+            <a:r>
+              <a:rPr lang="en-GB" dirty="0"/>
+              <a:t>, with honest limits (heuristic image QC, platform shift, etc.).</a:t>
             </a:r>
           </a:p>
           <a:p>
@@ -6879,7 +6166,7 @@
             </a:pPr>
             <a:r>
               <a:rPr lang="en-GB" dirty="0"/>
-              <a:t>Text text text text text text text text text text text text text text text text text text text text text text text text text text text text text text text text text text text text text text text text text text text text text text text text text text text text text text text.</a:t>
+              <a:t>.</a:t>
             </a:r>
           </a:p>
         </p:txBody>
@@ -6972,7 +6259,7 @@
         <p:spPr>
           <a:xfrm>
             <a:off x="15104553" y="24955702"/>
-            <a:ext cx="13284199" cy="2446335"/>
+            <a:ext cx="13284199" cy="2991943"/>
           </a:xfrm>
           <a:prstGeom prst="rect">
             <a:avLst/>
@@ -7153,343 +6440,55 @@
             </a:lvl9pPr>
           </a:lstStyle>
           <a:p>
-            <a:pPr>
-              <a:defRPr/>
-            </a:pPr>
-            <a:r>
-              <a:rPr lang="en-GB" dirty="0"/>
-              <a:t>Subtitle here</a:t>
+            <a:r>
+              <a:rPr lang="en-GB" b="1" dirty="0"/>
+              <a:t>Next steps </a:t>
             </a:r>
           </a:p>
           <a:p>
             <a:r>
+              <a:rPr lang="en-GB" b="1" dirty="0"/>
+              <a:t>Baselines:</a:t>
+            </a:r>
+            <a:r>
               <a:rPr lang="en-GB" dirty="0"/>
-              <a:t>Text text text text text text text text text text text text text text text text text text text text text text text text text text text text text text text text text text text text text text text text text text text text text text text text text text text text text text text text text text text text.</a:t>
+              <a:t> text-only and image-only models on the gated subset; then </a:t>
+            </a:r>
+            <a:r>
+              <a:rPr lang="en-GB" b="1" dirty="0"/>
+              <a:t>multimodal fusion</a:t>
+            </a:r>
+            <a:r>
+              <a:rPr lang="en-GB" dirty="0"/>
+              <a:t> comparisons (RQ2–RQ3).</a:t>
+            </a:r>
+          </a:p>
+          <a:p>
+            <a:r>
+              <a:rPr lang="en-GB" dirty="0"/>
+              <a:t>Report </a:t>
+            </a:r>
+            <a:r>
+              <a:rPr lang="en-GB" b="1" dirty="0"/>
+              <a:t>metrics + runtime</a:t>
+            </a:r>
+            <a:r>
+              <a:rPr lang="en-GB" dirty="0"/>
+              <a:t> (RQ1).</a:t>
+            </a:r>
+          </a:p>
+          <a:p>
+            <a:r>
+              <a:rPr lang="en-GB" b="1" dirty="0" err="1"/>
+              <a:t>Gradio</a:t>
+            </a:r>
+            <a:r>
+              <a:rPr lang="en-GB" dirty="0"/>
+              <a:t> proof-of-concept for interactive demo.</a:t>
             </a:r>
           </a:p>
         </p:txBody>
       </p:sp>
-      <p:grpSp>
-        <p:nvGrpSpPr>
-          <p:cNvPr id="20" name="Group 19">
-            <a:extLst>
-              <a:ext uri="{FF2B5EF4-FFF2-40B4-BE49-F238E27FC236}">
-                <a16:creationId xmlns:a16="http://schemas.microsoft.com/office/drawing/2014/main" id="{8507113A-8EA5-2E44-A2B5-7D0ADFDCC46B}"/>
-              </a:ext>
-            </a:extLst>
-          </p:cNvPr>
-          <p:cNvGrpSpPr/>
-          <p:nvPr/>
-        </p:nvGrpSpPr>
-        <p:grpSpPr>
-          <a:xfrm>
-            <a:off x="28836938" y="10471421"/>
-            <a:ext cx="8293353" cy="1485230"/>
-            <a:chOff x="15724188" y="28249739"/>
-            <a:chExt cx="12416609" cy="2223650"/>
-          </a:xfrm>
-        </p:grpSpPr>
-        <p:pic>
-          <p:nvPicPr>
-            <p:cNvPr id="21" name="Picture 20">
-              <a:extLst>
-                <a:ext uri="{FF2B5EF4-FFF2-40B4-BE49-F238E27FC236}">
-                  <a16:creationId xmlns:a16="http://schemas.microsoft.com/office/drawing/2014/main" id="{D079F986-39B0-D375-8BFA-104575560621}"/>
-                </a:ext>
-              </a:extLst>
-            </p:cNvPr>
-            <p:cNvPicPr>
-              <a:picLocks noChangeAspect="1"/>
-            </p:cNvPicPr>
-            <p:nvPr/>
-          </p:nvPicPr>
-          <p:blipFill>
-            <a:blip r:embed="rId3"/>
-            <a:stretch>
-              <a:fillRect/>
-            </a:stretch>
-          </p:blipFill>
-          <p:spPr>
-            <a:xfrm>
-              <a:off x="15724188" y="28249739"/>
-              <a:ext cx="1038683" cy="2219005"/>
-            </a:xfrm>
-            <a:prstGeom prst="rect">
-              <a:avLst/>
-            </a:prstGeom>
-          </p:spPr>
-        </p:pic>
-        <p:pic>
-          <p:nvPicPr>
-            <p:cNvPr id="22" name="Picture 21">
-              <a:extLst>
-                <a:ext uri="{FF2B5EF4-FFF2-40B4-BE49-F238E27FC236}">
-                  <a16:creationId xmlns:a16="http://schemas.microsoft.com/office/drawing/2014/main" id="{6F97B03E-0FCA-1BEB-FFBA-580145AAA842}"/>
-                </a:ext>
-              </a:extLst>
-            </p:cNvPr>
-            <p:cNvPicPr>
-              <a:picLocks noChangeAspect="1"/>
-            </p:cNvPicPr>
-            <p:nvPr/>
-          </p:nvPicPr>
-          <p:blipFill>
-            <a:blip r:embed="rId3"/>
-            <a:stretch>
-              <a:fillRect/>
-            </a:stretch>
-          </p:blipFill>
-          <p:spPr>
-            <a:xfrm>
-              <a:off x="16987926" y="28249739"/>
-              <a:ext cx="1038683" cy="2219005"/>
-            </a:xfrm>
-            <a:prstGeom prst="rect">
-              <a:avLst/>
-            </a:prstGeom>
-          </p:spPr>
-        </p:pic>
-        <p:pic>
-          <p:nvPicPr>
-            <p:cNvPr id="23" name="Picture 22">
-              <a:extLst>
-                <a:ext uri="{FF2B5EF4-FFF2-40B4-BE49-F238E27FC236}">
-                  <a16:creationId xmlns:a16="http://schemas.microsoft.com/office/drawing/2014/main" id="{2A23748B-CF25-664D-8E0F-9DC3BE5D7527}"/>
-                </a:ext>
-              </a:extLst>
-            </p:cNvPr>
-            <p:cNvPicPr>
-              <a:picLocks noChangeAspect="1"/>
-            </p:cNvPicPr>
-            <p:nvPr/>
-          </p:nvPicPr>
-          <p:blipFill>
-            <a:blip r:embed="rId3"/>
-            <a:stretch>
-              <a:fillRect/>
-            </a:stretch>
-          </p:blipFill>
-          <p:spPr>
-            <a:xfrm>
-              <a:off x="18251664" y="28249739"/>
-              <a:ext cx="1038683" cy="2219005"/>
-            </a:xfrm>
-            <a:prstGeom prst="rect">
-              <a:avLst/>
-            </a:prstGeom>
-          </p:spPr>
-        </p:pic>
-        <p:pic>
-          <p:nvPicPr>
-            <p:cNvPr id="24" name="Picture 23">
-              <a:extLst>
-                <a:ext uri="{FF2B5EF4-FFF2-40B4-BE49-F238E27FC236}">
-                  <a16:creationId xmlns:a16="http://schemas.microsoft.com/office/drawing/2014/main" id="{26E28872-9FC3-F574-64A0-FF2A1C181788}"/>
-                </a:ext>
-              </a:extLst>
-            </p:cNvPr>
-            <p:cNvPicPr>
-              <a:picLocks noChangeAspect="1"/>
-            </p:cNvPicPr>
-            <p:nvPr/>
-          </p:nvPicPr>
-          <p:blipFill>
-            <a:blip r:embed="rId3"/>
-            <a:stretch>
-              <a:fillRect/>
-            </a:stretch>
-          </p:blipFill>
-          <p:spPr>
-            <a:xfrm>
-              <a:off x="19516473" y="28249739"/>
-              <a:ext cx="1038683" cy="2219005"/>
-            </a:xfrm>
-            <a:prstGeom prst="rect">
-              <a:avLst/>
-            </a:prstGeom>
-          </p:spPr>
-        </p:pic>
-        <p:pic>
-          <p:nvPicPr>
-            <p:cNvPr id="25" name="Picture 24">
-              <a:extLst>
-                <a:ext uri="{FF2B5EF4-FFF2-40B4-BE49-F238E27FC236}">
-                  <a16:creationId xmlns:a16="http://schemas.microsoft.com/office/drawing/2014/main" id="{B690F46F-61BF-2CB5-0977-00D020BFD2D7}"/>
-                </a:ext>
-              </a:extLst>
-            </p:cNvPr>
-            <p:cNvPicPr>
-              <a:picLocks noChangeAspect="1"/>
-            </p:cNvPicPr>
-            <p:nvPr/>
-          </p:nvPicPr>
-          <p:blipFill>
-            <a:blip r:embed="rId4"/>
-            <a:stretch>
-              <a:fillRect/>
-            </a:stretch>
-          </p:blipFill>
-          <p:spPr>
-            <a:xfrm>
-              <a:off x="20777138" y="28254385"/>
-              <a:ext cx="1038683" cy="2219004"/>
-            </a:xfrm>
-            <a:prstGeom prst="rect">
-              <a:avLst/>
-            </a:prstGeom>
-          </p:spPr>
-        </p:pic>
-        <p:pic>
-          <p:nvPicPr>
-            <p:cNvPr id="26" name="Picture 25">
-              <a:extLst>
-                <a:ext uri="{FF2B5EF4-FFF2-40B4-BE49-F238E27FC236}">
-                  <a16:creationId xmlns:a16="http://schemas.microsoft.com/office/drawing/2014/main" id="{ACD1349A-BB22-DD49-CDBF-399C69B99FA4}"/>
-                </a:ext>
-              </a:extLst>
-            </p:cNvPr>
-            <p:cNvPicPr>
-              <a:picLocks noChangeAspect="1"/>
-            </p:cNvPicPr>
-            <p:nvPr/>
-          </p:nvPicPr>
-          <p:blipFill>
-            <a:blip r:embed="rId4"/>
-            <a:stretch>
-              <a:fillRect/>
-            </a:stretch>
-          </p:blipFill>
-          <p:spPr>
-            <a:xfrm>
-              <a:off x="22044829" y="28254385"/>
-              <a:ext cx="1038683" cy="2219004"/>
-            </a:xfrm>
-            <a:prstGeom prst="rect">
-              <a:avLst/>
-            </a:prstGeom>
-          </p:spPr>
-        </p:pic>
-        <p:pic>
-          <p:nvPicPr>
-            <p:cNvPr id="27" name="Picture 26">
-              <a:extLst>
-                <a:ext uri="{FF2B5EF4-FFF2-40B4-BE49-F238E27FC236}">
-                  <a16:creationId xmlns:a16="http://schemas.microsoft.com/office/drawing/2014/main" id="{3089EBC0-0966-B60C-F3AE-6217A1DE8DDA}"/>
-                </a:ext>
-              </a:extLst>
-            </p:cNvPr>
-            <p:cNvPicPr>
-              <a:picLocks noChangeAspect="1"/>
-            </p:cNvPicPr>
-            <p:nvPr/>
-          </p:nvPicPr>
-          <p:blipFill>
-            <a:blip r:embed="rId4"/>
-            <a:stretch>
-              <a:fillRect/>
-            </a:stretch>
-          </p:blipFill>
-          <p:spPr>
-            <a:xfrm>
-              <a:off x="23312520" y="28254385"/>
-              <a:ext cx="1038683" cy="2219004"/>
-            </a:xfrm>
-            <a:prstGeom prst="rect">
-              <a:avLst/>
-            </a:prstGeom>
-          </p:spPr>
-        </p:pic>
-        <p:pic>
-          <p:nvPicPr>
-            <p:cNvPr id="28" name="Picture 27">
-              <a:extLst>
-                <a:ext uri="{FF2B5EF4-FFF2-40B4-BE49-F238E27FC236}">
-                  <a16:creationId xmlns:a16="http://schemas.microsoft.com/office/drawing/2014/main" id="{FB481883-A8B9-5EC9-8443-E827F99852E2}"/>
-                </a:ext>
-              </a:extLst>
-            </p:cNvPr>
-            <p:cNvPicPr>
-              <a:picLocks noChangeAspect="1"/>
-            </p:cNvPicPr>
-            <p:nvPr/>
-          </p:nvPicPr>
-          <p:blipFill>
-            <a:blip r:embed="rId4"/>
-            <a:stretch>
-              <a:fillRect/>
-            </a:stretch>
-          </p:blipFill>
-          <p:spPr>
-            <a:xfrm>
-              <a:off x="24559430" y="28249740"/>
-              <a:ext cx="1038683" cy="2219004"/>
-            </a:xfrm>
-            <a:prstGeom prst="rect">
-              <a:avLst/>
-            </a:prstGeom>
-          </p:spPr>
-        </p:pic>
-        <p:pic>
-          <p:nvPicPr>
-            <p:cNvPr id="29" name="Picture 28">
-              <a:extLst>
-                <a:ext uri="{FF2B5EF4-FFF2-40B4-BE49-F238E27FC236}">
-                  <a16:creationId xmlns:a16="http://schemas.microsoft.com/office/drawing/2014/main" id="{40C725EC-CDBB-0F75-C5B3-6604BE705AD9}"/>
-                </a:ext>
-              </a:extLst>
-            </p:cNvPr>
-            <p:cNvPicPr>
-              <a:picLocks noChangeAspect="1"/>
-            </p:cNvPicPr>
-            <p:nvPr/>
-          </p:nvPicPr>
-          <p:blipFill>
-            <a:blip r:embed="rId4"/>
-            <a:stretch>
-              <a:fillRect/>
-            </a:stretch>
-          </p:blipFill>
-          <p:spPr>
-            <a:xfrm>
-              <a:off x="25828376" y="28249740"/>
-              <a:ext cx="1038683" cy="2219004"/>
-            </a:xfrm>
-            <a:prstGeom prst="rect">
-              <a:avLst/>
-            </a:prstGeom>
-          </p:spPr>
-        </p:pic>
-        <p:pic>
-          <p:nvPicPr>
-            <p:cNvPr id="30" name="Picture 29">
-              <a:extLst>
-                <a:ext uri="{FF2B5EF4-FFF2-40B4-BE49-F238E27FC236}">
-                  <a16:creationId xmlns:a16="http://schemas.microsoft.com/office/drawing/2014/main" id="{0009D499-F979-CB92-E4BD-39325D93B3F9}"/>
-                </a:ext>
-              </a:extLst>
-            </p:cNvPr>
-            <p:cNvPicPr>
-              <a:picLocks noChangeAspect="1"/>
-            </p:cNvPicPr>
-            <p:nvPr/>
-          </p:nvPicPr>
-          <p:blipFill>
-            <a:blip r:embed="rId4"/>
-            <a:stretch>
-              <a:fillRect/>
-            </a:stretch>
-          </p:blipFill>
-          <p:spPr>
-            <a:xfrm>
-              <a:off x="27102114" y="28249740"/>
-              <a:ext cx="1038683" cy="2219004"/>
-            </a:xfrm>
-            <a:prstGeom prst="rect">
-              <a:avLst/>
-            </a:prstGeom>
-          </p:spPr>
-        </p:pic>
-      </p:grpSp>
       <p:sp>
         <p:nvSpPr>
           <p:cNvPr id="32" name="Text Placeholder 35">
@@ -7507,7 +6506,7 @@
         <p:spPr>
           <a:xfrm>
             <a:off x="28891218" y="7803558"/>
-            <a:ext cx="13015608" cy="2446335"/>
+            <a:ext cx="13015608" cy="4936421"/>
           </a:xfrm>
           <a:prstGeom prst="rect">
             <a:avLst/>
@@ -7689,8 +6688,63 @@
           </a:lstStyle>
           <a:p>
             <a:r>
+              <a:rPr lang="en-GB" b="1" dirty="0"/>
+              <a:t>Planned modelling (high level)</a:t>
+            </a:r>
+            <a:endParaRPr lang="en-GB" dirty="0"/>
+          </a:p>
+          <a:p>
+            <a:r>
+              <a:rPr lang="en-GB" b="1" dirty="0"/>
+              <a:t>Unimodal baselines</a:t>
+            </a:r>
+            <a:r>
               <a:rPr lang="en-GB" dirty="0"/>
-              <a:t>Text text text text text text text text text text text text text text text text text text text text text text text text text text text text text text text text text text text text text text text text text text text text text text text text text text text text text text text text text text text text.</a:t>
+              <a:t> (e.g. transformer text encoder; CNN/</a:t>
+            </a:r>
+            <a:r>
+              <a:rPr lang="en-GB" dirty="0" err="1"/>
+              <a:t>ViT</a:t>
+            </a:r>
+            <a:r>
+              <a:rPr lang="en-GB" dirty="0"/>
+              <a:t>-style image encoder).</a:t>
+            </a:r>
+          </a:p>
+          <a:p>
+            <a:r>
+              <a:rPr lang="en-GB" b="1" dirty="0"/>
+              <a:t>Multimodal fusion</a:t>
+            </a:r>
+            <a:r>
+              <a:rPr lang="en-GB" dirty="0"/>
+              <a:t> variants for </a:t>
+            </a:r>
+            <a:r>
+              <a:rPr lang="en-GB" b="1" dirty="0"/>
+              <a:t>RQ2</a:t>
+            </a:r>
+            <a:r>
+              <a:rPr lang="en-GB" dirty="0"/>
+              <a:t>; ablations for </a:t>
+            </a:r>
+            <a:r>
+              <a:rPr lang="en-GB" b="1" dirty="0"/>
+              <a:t>RQ3</a:t>
+            </a:r>
+            <a:r>
+              <a:rPr lang="en-GB" dirty="0"/>
+              <a:t>.</a:t>
+            </a:r>
+          </a:p>
+          <a:p>
+            <a:r>
+              <a:rPr lang="en-GB" b="1" dirty="0"/>
+              <a:t>Evaluation:</a:t>
+            </a:r>
+            <a:r>
+              <a:rPr lang="en-GB" dirty="0"/>
+              <a:t> accuracy / F1, efficiency, error analysis; cross-dataset generalisation where feasible.</a:t>
             </a:r>
           </a:p>
         </p:txBody>
@@ -7711,7 +6765,7 @@
         </p:nvSpPr>
         <p:spPr>
           <a:xfrm>
-            <a:off x="28876555" y="13491152"/>
+            <a:off x="28689592" y="12016458"/>
             <a:ext cx="6298185" cy="6209114"/>
           </a:xfrm>
           <a:prstGeom prst="rect">
@@ -7918,7 +6972,7 @@
         </p:nvSpPr>
         <p:spPr>
           <a:xfrm>
-            <a:off x="35615208" y="13463443"/>
+            <a:off x="35375845" y="11987505"/>
             <a:ext cx="6298185" cy="6209114"/>
           </a:xfrm>
           <a:prstGeom prst="rect">
@@ -8395,40 +7449,15 @@
           </a:lstStyle>
           <a:p>
             <a:r>
-              <a:rPr lang="en-GB" dirty="0"/>
-              <a:t>Current Progress &amp; Preliminary Outputs</a:t>
-            </a:r>
+              <a:rPr lang="en-GB" b="1" dirty="0"/>
+              <a:t>Methods outlook &amp; contribution</a:t>
+            </a:r>
+          </a:p>
+          <a:p>
+            <a:endParaRPr lang="en-GB" dirty="0"/>
           </a:p>
         </p:txBody>
       </p:sp>
-      <p:graphicFrame>
-        <p:nvGraphicFramePr>
-          <p:cNvPr id="38" name="Chart 37">
-            <a:extLst>
-              <a:ext uri="{FF2B5EF4-FFF2-40B4-BE49-F238E27FC236}">
-                <a16:creationId xmlns:a16="http://schemas.microsoft.com/office/drawing/2014/main" id="{5B79C708-D4FB-B4FF-2879-178B4A49C8C8}"/>
-              </a:ext>
-            </a:extLst>
-          </p:cNvPr>
-          <p:cNvGraphicFramePr/>
-          <p:nvPr>
-            <p:extLst>
-              <p:ext uri="{D42A27DB-BD31-4B8C-83A1-F6EECF244321}">
-                <p14:modId xmlns:p14="http://schemas.microsoft.com/office/powerpoint/2010/main" val="160947630"/>
-              </p:ext>
-            </p:extLst>
-          </p:nvPr>
-        </p:nvGraphicFramePr>
-        <p:xfrm>
-          <a:off x="37287292" y="9038791"/>
-          <a:ext cx="4583022" cy="3963077"/>
-        </p:xfrm>
-        <a:graphic>
-          <a:graphicData uri="http://schemas.openxmlformats.org/drawingml/2006/chart">
-            <c:chart xmlns:c="http://schemas.openxmlformats.org/drawingml/2006/chart" xmlns:r="http://schemas.openxmlformats.org/officeDocument/2006/relationships" r:id="rId5"/>
-          </a:graphicData>
-        </a:graphic>
-      </p:graphicFrame>
       <p:sp>
         <p:nvSpPr>
           <p:cNvPr id="2" name="TextBox 1">
@@ -8460,6 +7489,593 @@
             <a:r>
               <a:rPr lang="en-US" dirty="0"/>
               <a:t>Please keep all images and text within the orange guides</a:t>
+            </a:r>
+          </a:p>
+        </p:txBody>
+      </p:sp>
+      <p:sp>
+        <p:nvSpPr>
+          <p:cNvPr id="42" name="Text Placeholder 35">
+            <a:extLst>
+              <a:ext uri="{FF2B5EF4-FFF2-40B4-BE49-F238E27FC236}">
+                <a16:creationId xmlns:a16="http://schemas.microsoft.com/office/drawing/2014/main" id="{DFF4591C-AF5B-0FF6-377C-7D221F9E6A4C}"/>
+              </a:ext>
+            </a:extLst>
+          </p:cNvPr>
+          <p:cNvSpPr txBox="1">
+            <a:spLocks/>
+          </p:cNvSpPr>
+          <p:nvPr/>
+        </p:nvSpPr>
+        <p:spPr>
+          <a:xfrm>
+            <a:off x="7084927" y="13008336"/>
+            <a:ext cx="6719143" cy="3306794"/>
+          </a:xfrm>
+          <a:prstGeom prst="rect">
+            <a:avLst/>
+          </a:prstGeom>
+        </p:spPr>
+        <p:txBody>
+          <a:bodyPr lIns="0" tIns="0" rIns="0" bIns="0">
+            <a:noAutofit/>
+          </a:bodyPr>
+          <a:lstStyle>
+            <a:lvl1pPr marL="0" indent="0" algn="l" defTabSz="1950836" rtl="0" eaLnBrk="1" latinLnBrk="0" hangingPunct="1">
+              <a:lnSpc>
+                <a:spcPct val="90000"/>
+              </a:lnSpc>
+              <a:spcBef>
+                <a:spcPts val="2134"/>
+              </a:spcBef>
+              <a:buFont typeface="Arial" panose="020B0604020202020204" pitchFamily="34" charset="0"/>
+              <a:buNone/>
+              <a:defRPr sz="3300" b="0" i="0" kern="1200">
+                <a:solidFill>
+                  <a:schemeClr val="bg1"/>
+                </a:solidFill>
+                <a:latin typeface="+mn-lt"/>
+                <a:ea typeface="+mn-ea"/>
+                <a:cs typeface="+mn-cs"/>
+              </a:defRPr>
+            </a:lvl1pPr>
+            <a:lvl2pPr marL="1463128" indent="-487711" algn="l" defTabSz="1950836" rtl="0" eaLnBrk="1" latinLnBrk="0" hangingPunct="1">
+              <a:lnSpc>
+                <a:spcPct val="90000"/>
+              </a:lnSpc>
+              <a:spcBef>
+                <a:spcPts val="1067"/>
+              </a:spcBef>
+              <a:buFont typeface="Arial" panose="020B0604020202020204" pitchFamily="34" charset="0"/>
+              <a:buChar char="•"/>
+              <a:defRPr sz="5119" b="0" i="0" kern="1200">
+                <a:solidFill>
+                  <a:schemeClr val="tx1"/>
+                </a:solidFill>
+                <a:latin typeface="+mn-lt"/>
+                <a:ea typeface="+mn-ea"/>
+                <a:cs typeface="+mn-cs"/>
+              </a:defRPr>
+            </a:lvl2pPr>
+            <a:lvl3pPr marL="2438547" indent="-487711" algn="l" defTabSz="1950836" rtl="0" eaLnBrk="1" latinLnBrk="0" hangingPunct="1">
+              <a:lnSpc>
+                <a:spcPct val="90000"/>
+              </a:lnSpc>
+              <a:spcBef>
+                <a:spcPts val="1067"/>
+              </a:spcBef>
+              <a:buFont typeface="Arial" panose="020B0604020202020204" pitchFamily="34" charset="0"/>
+              <a:buChar char="•"/>
+              <a:defRPr sz="4266" b="0" i="0" kern="1200">
+                <a:solidFill>
+                  <a:schemeClr val="tx1"/>
+                </a:solidFill>
+                <a:latin typeface="+mn-lt"/>
+                <a:ea typeface="+mn-ea"/>
+                <a:cs typeface="+mn-cs"/>
+              </a:defRPr>
+            </a:lvl3pPr>
+            <a:lvl4pPr marL="3413965" indent="-487711" algn="l" defTabSz="1950836" rtl="0" eaLnBrk="1" latinLnBrk="0" hangingPunct="1">
+              <a:lnSpc>
+                <a:spcPct val="90000"/>
+              </a:lnSpc>
+              <a:spcBef>
+                <a:spcPts val="1067"/>
+              </a:spcBef>
+              <a:buFont typeface="Arial" panose="020B0604020202020204" pitchFamily="34" charset="0"/>
+              <a:buChar char="•"/>
+              <a:defRPr sz="3838" b="0" i="0" kern="1200">
+                <a:solidFill>
+                  <a:schemeClr val="tx1"/>
+                </a:solidFill>
+                <a:latin typeface="+mn-lt"/>
+                <a:ea typeface="+mn-ea"/>
+                <a:cs typeface="+mn-cs"/>
+              </a:defRPr>
+            </a:lvl4pPr>
+            <a:lvl5pPr marL="4389381" indent="-487711" algn="l" defTabSz="1950836" rtl="0" eaLnBrk="1" latinLnBrk="0" hangingPunct="1">
+              <a:lnSpc>
+                <a:spcPct val="90000"/>
+              </a:lnSpc>
+              <a:spcBef>
+                <a:spcPts val="1067"/>
+              </a:spcBef>
+              <a:buFont typeface="Arial" panose="020B0604020202020204" pitchFamily="34" charset="0"/>
+              <a:buChar char="•"/>
+              <a:defRPr sz="3838" b="0" i="0" kern="1200">
+                <a:solidFill>
+                  <a:schemeClr val="tx1"/>
+                </a:solidFill>
+                <a:latin typeface="+mn-lt"/>
+                <a:ea typeface="+mn-ea"/>
+                <a:cs typeface="+mn-cs"/>
+              </a:defRPr>
+            </a:lvl5pPr>
+            <a:lvl6pPr marL="5364800" indent="-487711" algn="l" defTabSz="1950836" rtl="0" eaLnBrk="1" latinLnBrk="0" hangingPunct="1">
+              <a:lnSpc>
+                <a:spcPct val="90000"/>
+              </a:lnSpc>
+              <a:spcBef>
+                <a:spcPts val="1067"/>
+              </a:spcBef>
+              <a:buFont typeface="Arial" panose="020B0604020202020204" pitchFamily="34" charset="0"/>
+              <a:buChar char="•"/>
+              <a:defRPr sz="3838" kern="1200">
+                <a:solidFill>
+                  <a:schemeClr val="tx1"/>
+                </a:solidFill>
+                <a:latin typeface="+mn-lt"/>
+                <a:ea typeface="+mn-ea"/>
+                <a:cs typeface="+mn-cs"/>
+              </a:defRPr>
+            </a:lvl6pPr>
+            <a:lvl7pPr marL="6340220" indent="-487711" algn="l" defTabSz="1950836" rtl="0" eaLnBrk="1" latinLnBrk="0" hangingPunct="1">
+              <a:lnSpc>
+                <a:spcPct val="90000"/>
+              </a:lnSpc>
+              <a:spcBef>
+                <a:spcPts val="1067"/>
+              </a:spcBef>
+              <a:buFont typeface="Arial" panose="020B0604020202020204" pitchFamily="34" charset="0"/>
+              <a:buChar char="•"/>
+              <a:defRPr sz="3838" kern="1200">
+                <a:solidFill>
+                  <a:schemeClr val="tx1"/>
+                </a:solidFill>
+                <a:latin typeface="+mn-lt"/>
+                <a:ea typeface="+mn-ea"/>
+                <a:cs typeface="+mn-cs"/>
+              </a:defRPr>
+            </a:lvl7pPr>
+            <a:lvl8pPr marL="7315639" indent="-487711" algn="l" defTabSz="1950836" rtl="0" eaLnBrk="1" latinLnBrk="0" hangingPunct="1">
+              <a:lnSpc>
+                <a:spcPct val="90000"/>
+              </a:lnSpc>
+              <a:spcBef>
+                <a:spcPts val="1067"/>
+              </a:spcBef>
+              <a:buFont typeface="Arial" panose="020B0604020202020204" pitchFamily="34" charset="0"/>
+              <a:buChar char="•"/>
+              <a:defRPr sz="3838" kern="1200">
+                <a:solidFill>
+                  <a:schemeClr val="tx1"/>
+                </a:solidFill>
+                <a:latin typeface="+mn-lt"/>
+                <a:ea typeface="+mn-ea"/>
+                <a:cs typeface="+mn-cs"/>
+              </a:defRPr>
+            </a:lvl8pPr>
+            <a:lvl9pPr marL="8291055" indent="-487711" algn="l" defTabSz="1950836" rtl="0" eaLnBrk="1" latinLnBrk="0" hangingPunct="1">
+              <a:lnSpc>
+                <a:spcPct val="90000"/>
+              </a:lnSpc>
+              <a:spcBef>
+                <a:spcPts val="1067"/>
+              </a:spcBef>
+              <a:buFont typeface="Arial" panose="020B0604020202020204" pitchFamily="34" charset="0"/>
+              <a:buChar char="•"/>
+              <a:defRPr sz="3838" kern="1200">
+                <a:solidFill>
+                  <a:schemeClr val="tx1"/>
+                </a:solidFill>
+                <a:latin typeface="+mn-lt"/>
+                <a:ea typeface="+mn-ea"/>
+                <a:cs typeface="+mn-cs"/>
+              </a:defRPr>
+            </a:lvl9pPr>
+          </a:lstStyle>
+          <a:p>
+            <a:r>
+              <a:rPr lang="en-GB" b="1" dirty="0" err="1">
+                <a:solidFill>
+                  <a:schemeClr val="tx2"/>
+                </a:solidFill>
+              </a:rPr>
+              <a:t>FAKE:</a:t>
+            </a:r>
+            <a:r>
+              <a:rPr lang="en-GB" dirty="0" err="1">
+                <a:solidFill>
+                  <a:schemeClr val="tx2"/>
+                </a:solidFill>
+              </a:rPr>
+              <a:t>“Trump</a:t>
+            </a:r>
+            <a:r>
+              <a:rPr lang="en-GB" dirty="0">
+                <a:solidFill>
+                  <a:schemeClr val="tx2"/>
+                </a:solidFill>
+              </a:rPr>
+              <a:t> Labels News Media ‘Enemy Of The American People’”</a:t>
+            </a:r>
+          </a:p>
+          <a:p>
+            <a:r>
+              <a:rPr lang="en-GB" b="1" dirty="0" err="1">
+                <a:solidFill>
+                  <a:schemeClr val="tx2"/>
+                </a:solidFill>
+              </a:rPr>
+              <a:t>FakeNewsNet</a:t>
+            </a:r>
+            <a:r>
+              <a:rPr lang="en-GB" b="1" dirty="0">
+                <a:solidFill>
+                  <a:schemeClr val="tx2"/>
+                </a:solidFill>
+              </a:rPr>
+              <a:t> / </a:t>
+            </a:r>
+            <a:r>
+              <a:rPr lang="en-GB" b="1" dirty="0" err="1">
+                <a:solidFill>
+                  <a:schemeClr val="tx2"/>
+                </a:solidFill>
+              </a:rPr>
+              <a:t>GossipCop</a:t>
+            </a:r>
+            <a:br>
+              <a:rPr lang="en-GB" dirty="0">
+                <a:solidFill>
+                  <a:schemeClr val="tx2"/>
+                </a:solidFill>
+              </a:rPr>
+            </a:br>
+            <a:r>
+              <a:rPr lang="en-GB" dirty="0" err="1">
+                <a:solidFill>
+                  <a:schemeClr val="tx2"/>
+                </a:solidFill>
+              </a:rPr>
+              <a:t>sample_id</a:t>
+            </a:r>
+            <a:r>
+              <a:rPr lang="en-GB" dirty="0">
+                <a:solidFill>
+                  <a:schemeClr val="tx2"/>
+                </a:solidFill>
+              </a:rPr>
+              <a:t>: fnn:gossipcop:fake:gossipcop-4373322193</a:t>
+            </a:r>
+          </a:p>
+        </p:txBody>
+      </p:sp>
+      <p:pic>
+        <p:nvPicPr>
+          <p:cNvPr id="46" name="Picture 45" descr="A person in a suit walking with microphones&#10;&#10;AI-generated content may be incorrect.">
+            <a:extLst>
+              <a:ext uri="{FF2B5EF4-FFF2-40B4-BE49-F238E27FC236}">
+                <a16:creationId xmlns:a16="http://schemas.microsoft.com/office/drawing/2014/main" id="{BD2E06D3-D3B5-C5F0-C32A-545EE5227CE6}"/>
+              </a:ext>
+            </a:extLst>
+          </p:cNvPr>
+          <p:cNvPicPr>
+            <a:picLocks noChangeAspect="1"/>
+          </p:cNvPicPr>
+          <p:nvPr/>
+        </p:nvPicPr>
+        <p:blipFill>
+          <a:blip r:embed="rId3"/>
+          <a:stretch>
+            <a:fillRect/>
+          </a:stretch>
+        </p:blipFill>
+        <p:spPr>
+          <a:xfrm>
+            <a:off x="1805089" y="12901494"/>
+            <a:ext cx="4891770" cy="3419499"/>
+          </a:xfrm>
+          <a:prstGeom prst="rect">
+            <a:avLst/>
+          </a:prstGeom>
+        </p:spPr>
+      </p:pic>
+      <p:pic>
+        <p:nvPicPr>
+          <p:cNvPr id="48" name="Picture 47" descr="A group of people wearing hard hats&#10;&#10;AI-generated content may be incorrect.">
+            <a:extLst>
+              <a:ext uri="{FF2B5EF4-FFF2-40B4-BE49-F238E27FC236}">
+                <a16:creationId xmlns:a16="http://schemas.microsoft.com/office/drawing/2014/main" id="{8DE18489-D6A2-8746-CA80-2D79CA5B3987}"/>
+              </a:ext>
+            </a:extLst>
+          </p:cNvPr>
+          <p:cNvPicPr>
+            <a:picLocks noChangeAspect="1"/>
+          </p:cNvPicPr>
+          <p:nvPr/>
+        </p:nvPicPr>
+        <p:blipFill>
+          <a:blip r:embed="rId4"/>
+          <a:stretch>
+            <a:fillRect/>
+          </a:stretch>
+        </p:blipFill>
+        <p:spPr>
+          <a:xfrm>
+            <a:off x="1778865" y="16620563"/>
+            <a:ext cx="4917994" cy="3210018"/>
+          </a:xfrm>
+          <a:prstGeom prst="rect">
+            <a:avLst/>
+          </a:prstGeom>
+        </p:spPr>
+      </p:pic>
+      <p:sp>
+        <p:nvSpPr>
+          <p:cNvPr id="49" name="Text Placeholder 35">
+            <a:extLst>
+              <a:ext uri="{FF2B5EF4-FFF2-40B4-BE49-F238E27FC236}">
+                <a16:creationId xmlns:a16="http://schemas.microsoft.com/office/drawing/2014/main" id="{03E1F1DF-8615-A6A4-2DD0-982B6CC0CDD0}"/>
+              </a:ext>
+            </a:extLst>
+          </p:cNvPr>
+          <p:cNvSpPr txBox="1">
+            <a:spLocks/>
+          </p:cNvSpPr>
+          <p:nvPr/>
+        </p:nvSpPr>
+        <p:spPr>
+          <a:xfrm>
+            <a:off x="7039946" y="16771954"/>
+            <a:ext cx="6719143" cy="3306794"/>
+          </a:xfrm>
+          <a:prstGeom prst="rect">
+            <a:avLst/>
+          </a:prstGeom>
+        </p:spPr>
+        <p:txBody>
+          <a:bodyPr lIns="0" tIns="0" rIns="0" bIns="0">
+            <a:noAutofit/>
+          </a:bodyPr>
+          <a:lstStyle>
+            <a:lvl1pPr marL="0" indent="0" algn="l" defTabSz="1950836" rtl="0" eaLnBrk="1" latinLnBrk="0" hangingPunct="1">
+              <a:lnSpc>
+                <a:spcPct val="90000"/>
+              </a:lnSpc>
+              <a:spcBef>
+                <a:spcPts val="2134"/>
+              </a:spcBef>
+              <a:buFont typeface="Arial" panose="020B0604020202020204" pitchFamily="34" charset="0"/>
+              <a:buNone/>
+              <a:defRPr sz="3300" b="0" i="0" kern="1200">
+                <a:solidFill>
+                  <a:schemeClr val="bg1"/>
+                </a:solidFill>
+                <a:latin typeface="+mn-lt"/>
+                <a:ea typeface="+mn-ea"/>
+                <a:cs typeface="+mn-cs"/>
+              </a:defRPr>
+            </a:lvl1pPr>
+            <a:lvl2pPr marL="1463128" indent="-487711" algn="l" defTabSz="1950836" rtl="0" eaLnBrk="1" latinLnBrk="0" hangingPunct="1">
+              <a:lnSpc>
+                <a:spcPct val="90000"/>
+              </a:lnSpc>
+              <a:spcBef>
+                <a:spcPts val="1067"/>
+              </a:spcBef>
+              <a:buFont typeface="Arial" panose="020B0604020202020204" pitchFamily="34" charset="0"/>
+              <a:buChar char="•"/>
+              <a:defRPr sz="5119" b="0" i="0" kern="1200">
+                <a:solidFill>
+                  <a:schemeClr val="tx1"/>
+                </a:solidFill>
+                <a:latin typeface="+mn-lt"/>
+                <a:ea typeface="+mn-ea"/>
+                <a:cs typeface="+mn-cs"/>
+              </a:defRPr>
+            </a:lvl2pPr>
+            <a:lvl3pPr marL="2438547" indent="-487711" algn="l" defTabSz="1950836" rtl="0" eaLnBrk="1" latinLnBrk="0" hangingPunct="1">
+              <a:lnSpc>
+                <a:spcPct val="90000"/>
+              </a:lnSpc>
+              <a:spcBef>
+                <a:spcPts val="1067"/>
+              </a:spcBef>
+              <a:buFont typeface="Arial" panose="020B0604020202020204" pitchFamily="34" charset="0"/>
+              <a:buChar char="•"/>
+              <a:defRPr sz="4266" b="0" i="0" kern="1200">
+                <a:solidFill>
+                  <a:schemeClr val="tx1"/>
+                </a:solidFill>
+                <a:latin typeface="+mn-lt"/>
+                <a:ea typeface="+mn-ea"/>
+                <a:cs typeface="+mn-cs"/>
+              </a:defRPr>
+            </a:lvl3pPr>
+            <a:lvl4pPr marL="3413965" indent="-487711" algn="l" defTabSz="1950836" rtl="0" eaLnBrk="1" latinLnBrk="0" hangingPunct="1">
+              <a:lnSpc>
+                <a:spcPct val="90000"/>
+              </a:lnSpc>
+              <a:spcBef>
+                <a:spcPts val="1067"/>
+              </a:spcBef>
+              <a:buFont typeface="Arial" panose="020B0604020202020204" pitchFamily="34" charset="0"/>
+              <a:buChar char="•"/>
+              <a:defRPr sz="3838" b="0" i="0" kern="1200">
+                <a:solidFill>
+                  <a:schemeClr val="tx1"/>
+                </a:solidFill>
+                <a:latin typeface="+mn-lt"/>
+                <a:ea typeface="+mn-ea"/>
+                <a:cs typeface="+mn-cs"/>
+              </a:defRPr>
+            </a:lvl4pPr>
+            <a:lvl5pPr marL="4389381" indent="-487711" algn="l" defTabSz="1950836" rtl="0" eaLnBrk="1" latinLnBrk="0" hangingPunct="1">
+              <a:lnSpc>
+                <a:spcPct val="90000"/>
+              </a:lnSpc>
+              <a:spcBef>
+                <a:spcPts val="1067"/>
+              </a:spcBef>
+              <a:buFont typeface="Arial" panose="020B0604020202020204" pitchFamily="34" charset="0"/>
+              <a:buChar char="•"/>
+              <a:defRPr sz="3838" b="0" i="0" kern="1200">
+                <a:solidFill>
+                  <a:schemeClr val="tx1"/>
+                </a:solidFill>
+                <a:latin typeface="+mn-lt"/>
+                <a:ea typeface="+mn-ea"/>
+                <a:cs typeface="+mn-cs"/>
+              </a:defRPr>
+            </a:lvl5pPr>
+            <a:lvl6pPr marL="5364800" indent="-487711" algn="l" defTabSz="1950836" rtl="0" eaLnBrk="1" latinLnBrk="0" hangingPunct="1">
+              <a:lnSpc>
+                <a:spcPct val="90000"/>
+              </a:lnSpc>
+              <a:spcBef>
+                <a:spcPts val="1067"/>
+              </a:spcBef>
+              <a:buFont typeface="Arial" panose="020B0604020202020204" pitchFamily="34" charset="0"/>
+              <a:buChar char="•"/>
+              <a:defRPr sz="3838" kern="1200">
+                <a:solidFill>
+                  <a:schemeClr val="tx1"/>
+                </a:solidFill>
+                <a:latin typeface="+mn-lt"/>
+                <a:ea typeface="+mn-ea"/>
+                <a:cs typeface="+mn-cs"/>
+              </a:defRPr>
+            </a:lvl6pPr>
+            <a:lvl7pPr marL="6340220" indent="-487711" algn="l" defTabSz="1950836" rtl="0" eaLnBrk="1" latinLnBrk="0" hangingPunct="1">
+              <a:lnSpc>
+                <a:spcPct val="90000"/>
+              </a:lnSpc>
+              <a:spcBef>
+                <a:spcPts val="1067"/>
+              </a:spcBef>
+              <a:buFont typeface="Arial" panose="020B0604020202020204" pitchFamily="34" charset="0"/>
+              <a:buChar char="•"/>
+              <a:defRPr sz="3838" kern="1200">
+                <a:solidFill>
+                  <a:schemeClr val="tx1"/>
+                </a:solidFill>
+                <a:latin typeface="+mn-lt"/>
+                <a:ea typeface="+mn-ea"/>
+                <a:cs typeface="+mn-cs"/>
+              </a:defRPr>
+            </a:lvl7pPr>
+            <a:lvl8pPr marL="7315639" indent="-487711" algn="l" defTabSz="1950836" rtl="0" eaLnBrk="1" latinLnBrk="0" hangingPunct="1">
+              <a:lnSpc>
+                <a:spcPct val="90000"/>
+              </a:lnSpc>
+              <a:spcBef>
+                <a:spcPts val="1067"/>
+              </a:spcBef>
+              <a:buFont typeface="Arial" panose="020B0604020202020204" pitchFamily="34" charset="0"/>
+              <a:buChar char="•"/>
+              <a:defRPr sz="3838" kern="1200">
+                <a:solidFill>
+                  <a:schemeClr val="tx1"/>
+                </a:solidFill>
+                <a:latin typeface="+mn-lt"/>
+                <a:ea typeface="+mn-ea"/>
+                <a:cs typeface="+mn-cs"/>
+              </a:defRPr>
+            </a:lvl8pPr>
+            <a:lvl9pPr marL="8291055" indent="-487711" algn="l" defTabSz="1950836" rtl="0" eaLnBrk="1" latinLnBrk="0" hangingPunct="1">
+              <a:lnSpc>
+                <a:spcPct val="90000"/>
+              </a:lnSpc>
+              <a:spcBef>
+                <a:spcPts val="1067"/>
+              </a:spcBef>
+              <a:buFont typeface="Arial" panose="020B0604020202020204" pitchFamily="34" charset="0"/>
+              <a:buChar char="•"/>
+              <a:defRPr sz="3838" kern="1200">
+                <a:solidFill>
+                  <a:schemeClr val="tx1"/>
+                </a:solidFill>
+                <a:latin typeface="+mn-lt"/>
+                <a:ea typeface="+mn-ea"/>
+                <a:cs typeface="+mn-cs"/>
+              </a:defRPr>
+            </a:lvl9pPr>
+          </a:lstStyle>
+          <a:p>
+            <a:r>
+              <a:rPr lang="en-GB" b="1" dirty="0">
+                <a:solidFill>
+                  <a:schemeClr val="tx1"/>
+                </a:solidFill>
+              </a:rPr>
+              <a:t>REAL:</a:t>
+            </a:r>
+            <a:r>
+              <a:rPr lang="en-GB" dirty="0">
+                <a:solidFill>
+                  <a:schemeClr val="tx1"/>
+                </a:solidFill>
+              </a:rPr>
+              <a:t> “At Trump hotel site, immigrant workers wary”</a:t>
+            </a:r>
+          </a:p>
+          <a:p>
+            <a:br>
+              <a:rPr lang="en-GB" dirty="0">
+                <a:solidFill>
+                  <a:schemeClr val="tx1"/>
+                </a:solidFill>
+              </a:rPr>
+            </a:br>
+            <a:r>
+              <a:rPr lang="en-GB" b="1" dirty="0" err="1">
+                <a:solidFill>
+                  <a:schemeClr val="tx1"/>
+                </a:solidFill>
+              </a:rPr>
+              <a:t>FakeNewsNet</a:t>
+            </a:r>
+            <a:r>
+              <a:rPr lang="en-GB" b="1" dirty="0">
+                <a:solidFill>
+                  <a:schemeClr val="tx1"/>
+                </a:solidFill>
+              </a:rPr>
+              <a:t> / PolitiFact</a:t>
+            </a:r>
+            <a:br>
+              <a:rPr lang="en-GB" dirty="0">
+                <a:solidFill>
+                  <a:schemeClr val="tx1"/>
+                </a:solidFill>
+              </a:rPr>
+            </a:br>
+            <a:r>
+              <a:rPr lang="en-GB" dirty="0" err="1">
+                <a:solidFill>
+                  <a:schemeClr val="tx1"/>
+                </a:solidFill>
+              </a:rPr>
+              <a:t>sample_id</a:t>
+            </a:r>
+            <a:r>
+              <a:rPr lang="en-GB" dirty="0">
+                <a:solidFill>
+                  <a:schemeClr val="tx1"/>
+                </a:solidFill>
+              </a:rPr>
+              <a:t>: fnn:politifact:real:politifact13310</a:t>
             </a:r>
           </a:p>
         </p:txBody>
@@ -8974,14 +8590,12 @@
 </file>
 
 <file path=customXml/item1.xml><?xml version="1.0" encoding="utf-8"?>
-<p:properties xmlns:p="http://schemas.microsoft.com/office/2006/metadata/properties" xmlns:xsi="http://www.w3.org/2001/XMLSchema-instance" xmlns:pc="http://schemas.microsoft.com/office/infopath/2007/PartnerControls">
-  <documentManagement>
-    <TaxCatchAll xmlns="dd29aa29-5ec4-41d6-a8f0-1c0d3d335484" xsi:nil="true"/>
-    <lcf76f155ced4ddcb4097134ff3c332f xmlns="8c782783-32b0-4dcc-b311-37def6eee61e">
-      <Terms xmlns="http://schemas.microsoft.com/office/infopath/2007/PartnerControls"/>
-    </lcf76f155ced4ddcb4097134ff3c332f>
-  </documentManagement>
-</p:properties>
+<?mso-contentType ?>
+<FormTemplates xmlns="http://schemas.microsoft.com/sharepoint/v3/contenttype/forms">
+  <Display>DocumentLibraryForm</Display>
+  <Edit>DocumentLibraryForm</Edit>
+  <New>DocumentLibraryForm</New>
+</FormTemplates>
 </file>
 
 <file path=customXml/item2.xml><?xml version="1.0" encoding="utf-8"?>
@@ -9202,21 +8816,20 @@
 </file>
 
 <file path=customXml/item3.xml><?xml version="1.0" encoding="utf-8"?>
-<?mso-contentType ?>
-<FormTemplates xmlns="http://schemas.microsoft.com/sharepoint/v3/contenttype/forms">
-  <Display>DocumentLibraryForm</Display>
-  <Edit>DocumentLibraryForm</Edit>
-  <New>DocumentLibraryForm</New>
-</FormTemplates>
+<p:properties xmlns:p="http://schemas.microsoft.com/office/2006/metadata/properties" xmlns:xsi="http://www.w3.org/2001/XMLSchema-instance" xmlns:pc="http://schemas.microsoft.com/office/infopath/2007/PartnerControls">
+  <documentManagement>
+    <TaxCatchAll xmlns="dd29aa29-5ec4-41d6-a8f0-1c0d3d335484" xsi:nil="true"/>
+    <lcf76f155ced4ddcb4097134ff3c332f xmlns="8c782783-32b0-4dcc-b311-37def6eee61e">
+      <Terms xmlns="http://schemas.microsoft.com/office/infopath/2007/PartnerControls"/>
+    </lcf76f155ced4ddcb4097134ff3c332f>
+  </documentManagement>
+</p:properties>
 </file>
 
 <file path=customXml/itemProps1.xml><?xml version="1.0" encoding="utf-8"?>
-<ds:datastoreItem xmlns:ds="http://schemas.openxmlformats.org/officeDocument/2006/customXml" ds:itemID="{D7AC7C10-787C-438C-83F9-D4735B3AC646}">
+<ds:datastoreItem xmlns:ds="http://schemas.openxmlformats.org/officeDocument/2006/customXml" ds:itemID="{65C44C14-A229-44B2-8FB3-EA92AA79EFCE}">
   <ds:schemaRefs>
-    <ds:schemaRef ds:uri="http://schemas.microsoft.com/office/2006/metadata/properties"/>
-    <ds:schemaRef ds:uri="http://schemas.microsoft.com/office/infopath/2007/PartnerControls"/>
-    <ds:schemaRef ds:uri="dd29aa29-5ec4-41d6-a8f0-1c0d3d335484"/>
-    <ds:schemaRef ds:uri="8c782783-32b0-4dcc-b311-37def6eee61e"/>
+    <ds:schemaRef ds:uri="http://schemas.microsoft.com/sharepoint/v3/contenttype/forms"/>
   </ds:schemaRefs>
 </ds:datastoreItem>
 </file>
@@ -9241,9 +8854,12 @@
 </file>
 
 <file path=customXml/itemProps3.xml><?xml version="1.0" encoding="utf-8"?>
-<ds:datastoreItem xmlns:ds="http://schemas.openxmlformats.org/officeDocument/2006/customXml" ds:itemID="{65C44C14-A229-44B2-8FB3-EA92AA79EFCE}">
+<ds:datastoreItem xmlns:ds="http://schemas.openxmlformats.org/officeDocument/2006/customXml" ds:itemID="{D7AC7C10-787C-438C-83F9-D4735B3AC646}">
   <ds:schemaRefs>
-    <ds:schemaRef ds:uri="http://schemas.microsoft.com/sharepoint/v3/contenttype/forms"/>
+    <ds:schemaRef ds:uri="http://schemas.microsoft.com/office/2006/metadata/properties"/>
+    <ds:schemaRef ds:uri="http://schemas.microsoft.com/office/infopath/2007/PartnerControls"/>
+    <ds:schemaRef ds:uri="dd29aa29-5ec4-41d6-a8f0-1c0d3d335484"/>
+    <ds:schemaRef ds:uri="8c782783-32b0-4dcc-b311-37def6eee61e"/>
   </ds:schemaRefs>
 </ds:datastoreItem>
 </file>
</xml_diff>